<commit_message>
feat: rewrite poster at 24pt minimum, no en/em dashes, diagram-first layout
Agent-Logs-Url: https://github.com/Ghastmatron01/DissProject/sessions/d8436db5-feba-40f5-83a1-dca27a388bf1

Co-authored-by: Ghastmatron01 <271006317+Ghastmatron01@users.noreply.github.com>
</commit_message>
<xml_diff>
--- a/poster/poster.pptx
+++ b/poster/poster.pptx
@@ -3132,12 +3132,12 @@
           </a:fontRef>
         </p:style>
         <p:txBody>
-          <a:bodyPr rtlCol="0" anchor="ctr" wrap="square" lIns="432000" rIns="180000" tIns="72000" bIns="36000"/>
+          <a:bodyPr rtlCol="0" anchor="ctr" wrap="square" lIns="432000" rIns="180000" tIns="79200" bIns="36000"/>
           <a:lstStyle/>
           <a:p>
             <a:pPr algn="l"/>
             <a:r>
-              <a:rPr sz="950" b="1" i="0">
+              <a:rPr sz="1100" b="1" i="0">
                 <a:solidFill>
                   <a:srgbClr val="FFFFFF"/>
                 </a:solidFill>
@@ -3155,8 +3155,8 @@
         </p:nvSpPr>
         <p:spPr>
           <a:xfrm>
-            <a:off x="13067999" y="18000"/>
-            <a:ext cx="1872000" cy="756000"/>
+            <a:off x="12780000" y="18000"/>
+            <a:ext cx="2160000" cy="936000"/>
           </a:xfrm>
           <a:prstGeom prst="roundRect">
             <a:avLst>
@@ -3185,12 +3185,12 @@
           </a:fontRef>
         </p:style>
         <p:txBody>
-          <a:bodyPr rtlCol="0" anchor="ctr" wrap="square" lIns="54000" rIns="54000" tIns="64800" bIns="36000"/>
+          <a:bodyPr rtlCol="0" anchor="ctr" wrap="square" lIns="72000" rIns="72000" tIns="100800" bIns="36000"/>
           <a:lstStyle/>
           <a:p>
             <a:pPr algn="ctr"/>
             <a:r>
-              <a:rPr sz="950" b="1" i="0">
+              <a:rPr sz="1300" b="1" i="0">
                 <a:solidFill>
                   <a:srgbClr val="FFFFFF"/>
                 </a:solidFill>
@@ -3201,7 +3201,7 @@
           <a:p>
             <a:pPr algn="ctr"/>
             <a:r>
-              <a:rPr sz="950" b="0" i="0">
+              <a:rPr sz="1300" b="0" i="0">
                 <a:solidFill>
                   <a:srgbClr val="FFFFFF"/>
                 </a:solidFill>
@@ -3219,8 +3219,8 @@
         </p:nvSpPr>
         <p:spPr>
           <a:xfrm>
-            <a:off x="432000" y="648000"/>
-            <a:ext cx="12096000" cy="1044000"/>
+            <a:off x="432000" y="684000"/>
+            <a:ext cx="11736000" cy="1512000"/>
           </a:xfrm>
           <a:prstGeom prst="rect">
             <a:avLst/>
@@ -3234,7 +3234,7 @@
           <a:lstStyle/>
           <a:p>
             <a:r>
-              <a:rPr sz="2600" b="1" i="0">
+              <a:rPr sz="4800" b="1" i="0">
                 <a:solidFill>
                   <a:srgbClr val="003B6F"/>
                 </a:solidFill>
@@ -3252,8 +3252,8 @@
         </p:nvSpPr>
         <p:spPr>
           <a:xfrm>
-            <a:off x="432000" y="1728000"/>
-            <a:ext cx="14256000" cy="396000"/>
+            <a:off x="432000" y="2268000"/>
+            <a:ext cx="14256000" cy="540000"/>
           </a:xfrm>
           <a:prstGeom prst="rect">
             <a:avLst/>
@@ -3267,7 +3267,7 @@
           <a:lstStyle/>
           <a:p>
             <a:r>
-              <a:rPr sz="1400" b="0" i="0">
+              <a:rPr sz="3000" b="0" i="0">
                 <a:solidFill>
                   <a:srgbClr val="1A7A8A"/>
                 </a:solidFill>
@@ -3285,8 +3285,8 @@
         </p:nvSpPr>
         <p:spPr>
           <a:xfrm>
-            <a:off x="432000" y="2160000"/>
-            <a:ext cx="14256000" cy="234000"/>
+            <a:off x="432000" y="2844000"/>
+            <a:ext cx="14256000" cy="324000"/>
           </a:xfrm>
           <a:prstGeom prst="rect">
             <a:avLst/>
@@ -3300,12 +3300,12 @@
           <a:lstStyle/>
           <a:p>
             <a:r>
-              <a:rPr sz="850" b="0" i="0">
+              <a:rPr sz="2400" b="0" i="0">
                 <a:solidFill>
                   <a:srgbClr val="222222"/>
                 </a:solidFill>
               </a:rPr>
-              <a:t>Kieran Thompson  |  University of Reading  ·  Department of Computer Science  ·  2024/25</a:t>
+              <a:t>Kieran Thompson  |  University of Reading  |  Department of Computer Science  |  2024/25</a:t>
             </a:r>
           </a:p>
         </p:txBody>
@@ -3318,8 +3318,8 @@
         </p:nvSpPr>
         <p:spPr>
           <a:xfrm>
-            <a:off x="432000" y="2563200"/>
-            <a:ext cx="14256000" cy="25200"/>
+            <a:off x="432000" y="3186000"/>
+            <a:ext cx="14256000" cy="28800"/>
           </a:xfrm>
           <a:prstGeom prst="rect">
             <a:avLst/>
@@ -3361,8 +3361,8 @@
         </p:nvSpPr>
         <p:spPr>
           <a:xfrm>
-            <a:off x="0" y="20736000"/>
-            <a:ext cx="15120000" cy="648000"/>
+            <a:off x="0" y="20376000"/>
+            <a:ext cx="15120000" cy="1007999"/>
           </a:xfrm>
           <a:prstGeom prst="rect">
             <a:avLst/>
@@ -3404,8 +3404,8 @@
         </p:nvSpPr>
         <p:spPr>
           <a:xfrm>
-            <a:off x="432000" y="20779200"/>
-            <a:ext cx="9374400" cy="576000"/>
+            <a:off x="432000" y="20466000"/>
+            <a:ext cx="9072000" cy="881999"/>
           </a:xfrm>
           <a:prstGeom prst="rect">
             <a:avLst/>
@@ -3419,7 +3419,7 @@
           <a:lstStyle/>
           <a:p>
             <a:r>
-              <a:rPr sz="650" b="1" i="0">
+              <a:rPr sz="2400" b="1" i="0">
                 <a:solidFill>
                   <a:srgbClr val="FFFFFF"/>
                 </a:solidFill>
@@ -3429,22 +3429,22 @@
           </a:p>
           <a:p>
             <a:r>
-              <a:rPr sz="600" b="0" i="0">
+              <a:rPr sz="2400" b="0" i="0">
                 <a:solidFill>
                   <a:srgbClr val="FFFFFF"/>
                 </a:solidFill>
               </a:rPr>
-              <a:t>HM Land Registry (2024). UK House Price Index.   ONS (2023). UK House Price Statistics.   Bank of England (2024). Mortgage Market Data.</a:t>
-            </a:r>
-          </a:p>
-          <a:p>
-            <a:r>
-              <a:rPr sz="600" b="0" i="0">
+              <a:t>HM Land Registry (2024). UK House Price Index.  ONS (2023). UK House Price Statistics.  Bank of England (2024). Mortgage Market Data.</a:t>
+            </a:r>
+          </a:p>
+          <a:p>
+            <a:r>
+              <a:rPr sz="2400" b="0" i="0">
                 <a:solidFill>
                   <a:srgbClr val="FFFFFF"/>
                 </a:solidFill>
               </a:rPr>
-              <a:t>Bonabeau, E. (2002). Agent-based modeling. PNAS 99(S3).   Brown, T. et al. (2020). Language Models are Few-Shot Learners. NeurIPS.</a:t>
+              <a:t>Bonabeau, E. (2002). Agent-based modeling. PNAS 99(S3).  Brown, T. et al. (2020). Language Models are Few-Shot Learners. NeurIPS.</a:t>
             </a:r>
           </a:p>
         </p:txBody>
@@ -3457,8 +3457,8 @@
         </p:nvSpPr>
         <p:spPr>
           <a:xfrm>
-            <a:off x="9374400" y="20779200"/>
-            <a:ext cx="5313600" cy="576000"/>
+            <a:off x="9072000" y="20466000"/>
+            <a:ext cx="5616000" cy="881999"/>
           </a:xfrm>
           <a:prstGeom prst="rect">
             <a:avLst/>
@@ -3473,7 +3473,7 @@
           <a:p>
             <a:pPr algn="r"/>
             <a:r>
-              <a:rPr sz="650" b="1" i="0">
+              <a:rPr sz="2400" b="1" i="0">
                 <a:solidFill>
                   <a:srgbClr val="FFFFFF"/>
                 </a:solidFill>
@@ -3484,12 +3484,12 @@
           <a:p>
             <a:pPr algn="r"/>
             <a:r>
-              <a:rPr sz="600" b="0" i="0">
+              <a:rPr sz="2400" b="0" i="0">
                 <a:solidFill>
                   <a:srgbClr val="FFFFFF"/>
                 </a:solidFill>
               </a:rPr>
-              <a:t>BSc Computer Science  ·  University of Reading</a:t>
+              <a:t>BSc Computer Science  |  University of Reading</a:t>
             </a:r>
           </a:p>
         </p:txBody>
@@ -3502,8 +3502,8 @@
         </p:nvSpPr>
         <p:spPr>
           <a:xfrm>
-            <a:off x="432000" y="2772000"/>
-            <a:ext cx="6984000" cy="244800"/>
+            <a:off x="432000" y="3348000"/>
+            <a:ext cx="6984000" cy="468000"/>
           </a:xfrm>
           <a:prstGeom prst="roundRect">
             <a:avLst>
@@ -3532,12 +3532,12 @@
           </a:fontRef>
         </p:style>
         <p:txBody>
-          <a:bodyPr rtlCol="0" anchor="ctr" wrap="square" lIns="79200" rIns="43200" tIns="28800" bIns="28800"/>
+          <a:bodyPr rtlCol="0" anchor="ctr" wrap="square" lIns="79200" rIns="43200" tIns="43200" bIns="43200"/>
           <a:lstStyle/>
           <a:p>
             <a:pPr algn="l"/>
             <a:r>
-              <a:rPr sz="850" b="1" i="0">
+              <a:rPr sz="2600" b="1" i="0">
                 <a:solidFill>
                   <a:srgbClr val="FFFFFF"/>
                 </a:solidFill>
@@ -3555,8 +3555,8 @@
         </p:nvSpPr>
         <p:spPr>
           <a:xfrm>
-            <a:off x="432000" y="3088800"/>
-            <a:ext cx="6984000" cy="1908000"/>
+            <a:off x="432000" y="3906000"/>
+            <a:ext cx="6984000" cy="2340000"/>
           </a:xfrm>
           <a:prstGeom prst="rect">
             <a:avLst/>
@@ -3571,46 +3571,16 @@
           <a:p>
             <a:pPr>
               <a:spcAft>
-                <a:spcPts val="400"/>
+                <a:spcPts val="500"/>
               </a:spcAft>
             </a:pPr>
             <a:r>
-              <a:rPr sz="700" b="0" i="0">
+              <a:rPr sz="2400" b="0" i="0">
                 <a:solidFill>
                   <a:srgbClr val="222222"/>
                 </a:solidFill>
               </a:rPr>
-              <a:t>The United Kingdom faces a severe housing affordability crisis. National median house prices have risen to over 8× median annual household earnings, pricing millions of first-time buyers out of the market. In Greater London this ratio exceeds 12×, creating a stark structural divide. Despite decades of policy intervention — Help-to-Buy, Shared Ownership, stamp-duty relief — homeownership rates among the under-35s have fallen steadily since 2003.</a:t>
-            </a:r>
-          </a:p>
-          <a:p>
-            <a:pPr>
-              <a:spcAft>
-                <a:spcPts val="400"/>
-              </a:spcAft>
-            </a:pPr>
-            <a:r>
-              <a:rPr sz="700" b="0" i="0">
-                <a:solidFill>
-                  <a:srgbClr val="222222"/>
-                </a:solidFill>
-              </a:rPr>
-              <a:t>Traditional econometric models rely on aggregate supply-demand assumptions that fail to capture the emergent, heterogeneous behaviours driving real housing markets. Individual household decisions — shaped by income, life stage, debt, and local conditions — aggregate into complex dynamics that are fundamentally non-linear and path-dependent.</a:t>
-            </a:r>
-          </a:p>
-          <a:p>
-            <a:pPr>
-              <a:spcAft>
-                <a:spcPts val="400"/>
-              </a:spcAft>
-            </a:pPr>
-            <a:r>
-              <a:rPr sz="700" b="0" i="0">
-                <a:solidFill>
-                  <a:srgbClr val="222222"/>
-                </a:solidFill>
-              </a:rPr>
-              <a:t>This research presents a novel Agent-Based Model (ABM) combining Large Language Model (LLM) reasoning with rigorous quantitative financial algorithms. Each agent represents a unique household navigating realistic constraints across a 10-year simulation horizon, producing outputs suitable for policy evaluation.</a:t>
+              <a:t>UK house prices now exceed 8x median earnings nationally, rising above 12x in London. Under-35 homeownership has fallen since 2003 despite repeated policy intervention. This project builds an LLM-driven Agent-Based Model to simulate UK housing affordability across a 10-year horizon.</a:t>
             </a:r>
           </a:p>
         </p:txBody>
@@ -3623,8 +3593,8 @@
         </p:nvSpPr>
         <p:spPr>
           <a:xfrm>
-            <a:off x="432000" y="5122799"/>
-            <a:ext cx="6984000" cy="244800"/>
+            <a:off x="432000" y="6408000"/>
+            <a:ext cx="6984000" cy="468000"/>
           </a:xfrm>
           <a:prstGeom prst="roundRect">
             <a:avLst>
@@ -3653,12 +3623,12 @@
           </a:fontRef>
         </p:style>
         <p:txBody>
-          <a:bodyPr rtlCol="0" anchor="ctr" wrap="square" lIns="79200" rIns="43200" tIns="28800" bIns="28800"/>
+          <a:bodyPr rtlCol="0" anchor="ctr" wrap="square" lIns="79200" rIns="43200" tIns="43200" bIns="43200"/>
           <a:lstStyle/>
           <a:p>
             <a:pPr algn="l"/>
             <a:r>
-              <a:rPr sz="850" b="1" i="0">
+              <a:rPr sz="2600" b="1" i="0">
                 <a:solidFill>
                   <a:srgbClr val="FFFFFF"/>
                 </a:solidFill>
@@ -3676,8 +3646,8 @@
         </p:nvSpPr>
         <p:spPr>
           <a:xfrm>
-            <a:off x="432000" y="5439599"/>
-            <a:ext cx="6984000" cy="1152000"/>
+            <a:off x="432000" y="6966000"/>
+            <a:ext cx="6984000" cy="2880000"/>
           </a:xfrm>
           <a:prstGeom prst="rect">
             <a:avLst/>
@@ -3692,70 +3662,70 @@
           <a:p>
             <a:pPr>
               <a:spcAft>
-                <a:spcPts val="300"/>
+                <a:spcPts val="600"/>
               </a:spcAft>
             </a:pPr>
             <a:r>
-              <a:rPr sz="650" b="1" i="0">
+              <a:rPr sz="2400" b="1" i="0">
                 <a:solidFill>
                   <a:srgbClr val="1A7A8A"/>
                 </a:solidFill>
               </a:rPr>
-              <a:t>▶  </a:t>
-            </a:r>
-            <a:r>
-              <a:rPr sz="650" b="0" i="0">
+              <a:t>  </a:t>
+            </a:r>
+            <a:r>
+              <a:rPr sz="2400" b="0" i="0">
                 <a:solidFill>
                   <a:srgbClr val="222222"/>
                 </a:solidFill>
               </a:rPr>
-              <a:t>Can LLM-driven agents produce contextually appropriate housing decisions consistent with empirically observed UK behavioural patterns?</a:t>
+              <a:t>Q1  Can LLM-driven agents reproduce UK housing decisions?</a:t>
             </a:r>
           </a:p>
           <a:p>
             <a:pPr>
               <a:spcAft>
-                <a:spcPts val="300"/>
+                <a:spcPts val="600"/>
               </a:spcAft>
             </a:pPr>
             <a:r>
-              <a:rPr sz="650" b="1" i="0">
+              <a:rPr sz="2400" b="1" i="0">
                 <a:solidFill>
                   <a:srgbClr val="1A7A8A"/>
                 </a:solidFill>
               </a:rPr>
-              <a:t>▶  </a:t>
-            </a:r>
-            <a:r>
-              <a:rPr sz="650" b="0" i="0">
+              <a:t>  </a:t>
+            </a:r>
+            <a:r>
+              <a:rPr sz="2400" b="0" i="0">
                 <a:solidFill>
                   <a:srgbClr val="222222"/>
                 </a:solidFill>
               </a:rPr>
-              <a:t>How do heterogeneous agent decisions compare across income groups, ages, and regions over a 10-year simulation horizon?</a:t>
+              <a:t>Q2  How do decisions vary by income, age and region over 10 years?</a:t>
             </a:r>
           </a:p>
           <a:p>
             <a:pPr>
               <a:spcAft>
-                <a:spcPts val="300"/>
+                <a:spcPts val="600"/>
               </a:spcAft>
             </a:pPr>
             <a:r>
-              <a:rPr sz="650" b="1" i="0">
+              <a:rPr sz="2400" b="1" i="0">
                 <a:solidFill>
                   <a:srgbClr val="1A7A8A"/>
                 </a:solidFill>
               </a:rPr>
-              <a:t>▶  </a:t>
-            </a:r>
-            <a:r>
-              <a:rPr sz="650" b="0" i="0">
+              <a:t>  </a:t>
+            </a:r>
+            <a:r>
+              <a:rPr sz="2400" b="0" i="0">
                 <a:solidFill>
                   <a:srgbClr val="222222"/>
                 </a:solidFill>
               </a:rPr>
-              <a:t>Which policy interventions — Help-to-Buy, interest-rate changes, shared ownership — most effectively improve affordability for target demographics?</a:t>
+              <a:t>Q3  Which policy interventions best improve affordability?</a:t>
             </a:r>
           </a:p>
         </p:txBody>
@@ -3768,8 +3738,8 @@
         </p:nvSpPr>
         <p:spPr>
           <a:xfrm>
-            <a:off x="432000" y="6717600"/>
-            <a:ext cx="6984000" cy="244800"/>
+            <a:off x="432000" y="10008000"/>
+            <a:ext cx="6984000" cy="468000"/>
           </a:xfrm>
           <a:prstGeom prst="roundRect">
             <a:avLst>
@@ -3798,12 +3768,12 @@
           </a:fontRef>
         </p:style>
         <p:txBody>
-          <a:bodyPr rtlCol="0" anchor="ctr" wrap="square" lIns="79200" rIns="43200" tIns="28800" bIns="28800"/>
+          <a:bodyPr rtlCol="0" anchor="ctr" wrap="square" lIns="79200" rIns="43200" tIns="43200" bIns="43200"/>
           <a:lstStyle/>
           <a:p>
             <a:pPr algn="l"/>
             <a:r>
-              <a:rPr sz="850" b="1" i="0">
+              <a:rPr sz="2600" b="1" i="0">
                 <a:solidFill>
                   <a:srgbClr val="FFFFFF"/>
                 </a:solidFill>
@@ -3821,8 +3791,8 @@
         </p:nvSpPr>
         <p:spPr>
           <a:xfrm>
-            <a:off x="432000" y="7034400"/>
-            <a:ext cx="6984000" cy="612000"/>
+            <a:off x="432000" y="10566000"/>
+            <a:ext cx="6984000" cy="1440000"/>
           </a:xfrm>
           <a:prstGeom prst="rect">
             <a:avLst/>
@@ -3837,16 +3807,16 @@
           <a:p>
             <a:pPr>
               <a:spcAft>
-                <a:spcPts val="200"/>
+                <a:spcPts val="300"/>
               </a:spcAft>
             </a:pPr>
             <a:r>
-              <a:rPr sz="650" b="0" i="0">
+              <a:rPr sz="2400" b="0" i="0">
                 <a:solidFill>
                   <a:srgbClr val="222222"/>
                 </a:solidFill>
               </a:rPr>
-              <a:t>Each agent encapsulates a household with unique financial circumstances, life-stage preferences, and decision-making characteristics. The hybrid LLM + algorithm design ensures decisions are simultaneously contextually intelligent (via language model reasoning) and financially rigorous (via validated economic algorithms).</a:t>
+              <a:t>Each household agent uses LLM contextual reasoning backed by rigorous financial algorithms. The pipeline runs for 10 annual timesteps with stochastic life events.</a:t>
             </a:r>
           </a:p>
         </p:txBody>
@@ -3859,8 +3829,8 @@
         </p:nvSpPr>
         <p:spPr>
           <a:xfrm>
-            <a:off x="432000" y="7736399"/>
-            <a:ext cx="1620000" cy="439200"/>
+            <a:off x="432000" y="12078000"/>
+            <a:ext cx="1440000" cy="594000"/>
           </a:xfrm>
           <a:prstGeom prst="rect">
             <a:avLst/>
@@ -3889,18 +3859,17 @@
           </a:fontRef>
         </p:style>
         <p:txBody>
-          <a:bodyPr rtlCol="0" anchor="ctr" wrap="square" lIns="43200" rIns="28800" tIns="36000" bIns="36000"/>
+          <a:bodyPr rtlCol="0" anchor="ctr" wrap="square" lIns="54000" rIns="36000" tIns="54000" bIns="54000"/>
           <a:lstStyle/>
           <a:p>
             <a:pPr algn="ctr"/>
             <a:r>
-              <a:rPr sz="600" b="1" i="0">
+              <a:rPr sz="2400" b="1" i="0">
                 <a:solidFill>
                   <a:srgbClr val="FFFFFF"/>
                 </a:solidFill>
               </a:rPr>
-              <a:t>DATA
-COLLECTION</a:t>
+              <a:t>DATA</a:t>
             </a:r>
           </a:p>
         </p:txBody>
@@ -3913,8 +3882,8 @@
         </p:nvSpPr>
         <p:spPr>
           <a:xfrm>
-            <a:off x="2066400" y="7736399"/>
-            <a:ext cx="5349600" cy="439200"/>
+            <a:off x="1893600" y="12078000"/>
+            <a:ext cx="5522400" cy="594000"/>
           </a:xfrm>
           <a:prstGeom prst="rect">
             <a:avLst/>
@@ -3943,36 +3912,17 @@
           </a:fontRef>
         </p:style>
         <p:txBody>
-          <a:bodyPr rtlCol="0" anchor="ctr" wrap="square" lIns="64800" rIns="36000" tIns="36000" bIns="36000"/>
-          <a:lstStyle/>
-          <a:p>
-            <a:pPr algn="ctr">
-              <a:spcAft>
-                <a:spcPts val="100"/>
-              </a:spcAft>
-            </a:pPr>
-            <a:r>
-              <a:rPr sz="600" b="0" i="0">
+          <a:bodyPr rtlCol="0" anchor="ctr" wrap="square" lIns="72000" rIns="36000" tIns="54000" bIns="54000"/>
+          <a:lstStyle/>
+          <a:p>
+            <a:pPr algn="ctr"/>
+            <a:r>
+              <a:rPr sz="2400" b="0" i="0">
                 <a:solidFill>
                   <a:srgbClr val="222222"/>
                 </a:solidFill>
               </a:rPr>
-              <a:t>• HM Land Registry CSVs (2020–2024)</a:t>
-            </a:r>
-          </a:p>
-          <a:p>
-            <a:pPr>
-              <a:spcAft>
-                <a:spcPts val="100"/>
-              </a:spcAft>
-            </a:pPr>
-            <a:r>
-              <a:rPr sz="600" b="0" i="0">
-                <a:solidFill>
-                  <a:srgbClr val="222222"/>
-                </a:solidFill>
-              </a:rPr>
-              <a:t>• ONS income survey · BoE base rates</a:t>
+              <a:t>Land Registry, ONS and BoE: collection and preprocessing</a:t>
             </a:r>
           </a:p>
         </p:txBody>
@@ -3985,14 +3935,14 @@
         </p:nvSpPr>
         <p:spPr>
           <a:xfrm>
-            <a:off x="432000" y="8190000"/>
-            <a:ext cx="1620000" cy="439200"/>
+            <a:off x="432000" y="12693600"/>
+            <a:ext cx="1440000" cy="594000"/>
           </a:xfrm>
           <a:prstGeom prst="rect">
             <a:avLst/>
           </a:prstGeom>
           <a:solidFill>
-            <a:srgbClr val="1A6BB5"/>
+            <a:srgbClr val="1A7A8A"/>
           </a:solidFill>
           <a:ln w="6350">
             <a:solidFill>
@@ -4015,18 +3965,17 @@
           </a:fontRef>
         </p:style>
         <p:txBody>
-          <a:bodyPr rtlCol="0" anchor="ctr" wrap="square" lIns="43200" rIns="28800" tIns="36000" bIns="36000"/>
+          <a:bodyPr rtlCol="0" anchor="ctr" wrap="square" lIns="54000" rIns="36000" tIns="54000" bIns="54000"/>
           <a:lstStyle/>
           <a:p>
             <a:pPr algn="ctr"/>
             <a:r>
-              <a:rPr sz="600" b="1" i="0">
+              <a:rPr sz="2400" b="1" i="0">
                 <a:solidFill>
                   <a:srgbClr val="FFFFFF"/>
                 </a:solidFill>
               </a:rPr>
-              <a:t>DATA
-PREP</a:t>
+              <a:t>SETUP</a:t>
             </a:r>
           </a:p>
         </p:txBody>
@@ -4039,8 +3988,8 @@
         </p:nvSpPr>
         <p:spPr>
           <a:xfrm>
-            <a:off x="2066400" y="8190000"/>
-            <a:ext cx="5349600" cy="439200"/>
+            <a:off x="1893600" y="12693600"/>
+            <a:ext cx="5522400" cy="594000"/>
           </a:xfrm>
           <a:prstGeom prst="rect">
             <a:avLst/>
@@ -4069,36 +4018,17 @@
           </a:fontRef>
         </p:style>
         <p:txBody>
-          <a:bodyPr rtlCol="0" anchor="ctr" wrap="square" lIns="64800" rIns="36000" tIns="36000" bIns="36000"/>
-          <a:lstStyle/>
-          <a:p>
-            <a:pPr algn="ctr">
-              <a:spcAft>
-                <a:spcPts val="100"/>
-              </a:spcAft>
-            </a:pPr>
-            <a:r>
-              <a:rPr sz="600" b="0" i="0">
+          <a:bodyPr rtlCol="0" anchor="ctr" wrap="square" lIns="72000" rIns="36000" tIns="54000" bIns="54000"/>
+          <a:lstStyle/>
+          <a:p>
+            <a:pPr algn="ctr"/>
+            <a:r>
+              <a:rPr sz="2400" b="0" i="0">
                 <a:solidFill>
                   <a:srgbClr val="222222"/>
                 </a:solidFill>
               </a:rPr>
-              <a:t>• Fuzzy county normalisation · Outlier removal</a:t>
-            </a:r>
-          </a:p>
-          <a:p>
-            <a:pPr>
-              <a:spcAft>
-                <a:spcPts val="100"/>
-              </a:spcAft>
-            </a:pPr>
-            <a:r>
-              <a:rPr sz="600" b="0" i="0">
-                <a:solidFill>
-                  <a:srgbClr val="222222"/>
-                </a:solidFill>
-              </a:rPr>
-              <a:t>• Affordability feature engineering</a:t>
+              <a:t>Agent initialisation: income profiling and life-stage scoring</a:t>
             </a:r>
           </a:p>
         </p:txBody>
@@ -4111,8 +4041,8 @@
         </p:nvSpPr>
         <p:spPr>
           <a:xfrm>
-            <a:off x="432000" y="8643600"/>
-            <a:ext cx="1620000" cy="439200"/>
+            <a:off x="432000" y="13309200"/>
+            <a:ext cx="1440000" cy="594000"/>
           </a:xfrm>
           <a:prstGeom prst="rect">
             <a:avLst/>
@@ -4141,18 +4071,17 @@
           </a:fontRef>
         </p:style>
         <p:txBody>
-          <a:bodyPr rtlCol="0" anchor="ctr" wrap="square" lIns="43200" rIns="28800" tIns="36000" bIns="36000"/>
+          <a:bodyPr rtlCol="0" anchor="ctr" wrap="square" lIns="54000" rIns="36000" tIns="54000" bIns="54000"/>
           <a:lstStyle/>
           <a:p>
             <a:pPr algn="ctr"/>
             <a:r>
-              <a:rPr sz="600" b="1" i="0">
+              <a:rPr sz="2400" b="1" i="0">
                 <a:solidFill>
                   <a:srgbClr val="FFFFFF"/>
                 </a:solidFill>
               </a:rPr>
-              <a:t>AGENT
-SETUP</a:t>
+              <a:t>LOOP</a:t>
             </a:r>
           </a:p>
         </p:txBody>
@@ -4165,8 +4094,8 @@
         </p:nvSpPr>
         <p:spPr>
           <a:xfrm>
-            <a:off x="2066400" y="8643600"/>
-            <a:ext cx="5349600" cy="439200"/>
+            <a:off x="1893600" y="13309200"/>
+            <a:ext cx="5522400" cy="594000"/>
           </a:xfrm>
           <a:prstGeom prst="rect">
             <a:avLst/>
@@ -4195,36 +4124,17 @@
           </a:fontRef>
         </p:style>
         <p:txBody>
-          <a:bodyPr rtlCol="0" anchor="ctr" wrap="square" lIns="64800" rIns="36000" tIns="36000" bIns="36000"/>
-          <a:lstStyle/>
-          <a:p>
-            <a:pPr algn="ctr">
-              <a:spcAft>
-                <a:spcPts val="100"/>
-              </a:spcAft>
-            </a:pPr>
-            <a:r>
-              <a:rPr sz="600" b="0" i="0">
+          <a:bodyPr rtlCol="0" anchor="ctr" wrap="square" lIns="72000" rIns="36000" tIns="54000" bIns="54000"/>
+          <a:lstStyle/>
+          <a:p>
+            <a:pPr algn="ctr"/>
+            <a:r>
+              <a:rPr sz="2400" b="0" i="0">
                 <a:solidFill>
                   <a:srgbClr val="222222"/>
                 </a:solidFill>
               </a:rPr>
-              <a:t>• ONS income-percentile profiling</a:t>
-            </a:r>
-          </a:p>
-          <a:p>
-            <a:pPr>
-              <a:spcAft>
-                <a:spcPts val="100"/>
-              </a:spcAft>
-            </a:pPr>
-            <a:r>
-              <a:rPr sz="600" b="0" i="0">
-                <a:solidFill>
-                  <a:srgbClr val="222222"/>
-                </a:solidFill>
-              </a:rPr>
-              <a:t>• Life-stage classification · Preference scoring</a:t>
+              <a:t>LLM ReAct cycle with 4 specialist tools per annual timestep</a:t>
             </a:r>
           </a:p>
         </p:txBody>
@@ -4237,14 +4147,14 @@
         </p:nvSpPr>
         <p:spPr>
           <a:xfrm>
-            <a:off x="432000" y="9097200"/>
-            <a:ext cx="1620000" cy="439200"/>
+            <a:off x="432000" y="13924800"/>
+            <a:ext cx="1440000" cy="594000"/>
           </a:xfrm>
           <a:prstGeom prst="rect">
             <a:avLst/>
           </a:prstGeom>
           <a:solidFill>
-            <a:srgbClr val="1A7A8A"/>
+            <a:srgbClr val="A04010"/>
           </a:solidFill>
           <a:ln w="6350">
             <a:solidFill>
@@ -4267,18 +4177,17 @@
           </a:fontRef>
         </p:style>
         <p:txBody>
-          <a:bodyPr rtlCol="0" anchor="ctr" wrap="square" lIns="43200" rIns="28800" tIns="36000" bIns="36000"/>
+          <a:bodyPr rtlCol="0" anchor="ctr" wrap="square" lIns="54000" rIns="36000" tIns="54000" bIns="54000"/>
           <a:lstStyle/>
           <a:p>
             <a:pPr algn="ctr"/>
             <a:r>
-              <a:rPr sz="600" b="1" i="0">
+              <a:rPr sz="2400" b="1" i="0">
                 <a:solidFill>
                   <a:srgbClr val="FFFFFF"/>
                 </a:solidFill>
               </a:rPr>
-              <a:t>LLM +
-TOOLS</a:t>
+              <a:t>SIMULATE</a:t>
             </a:r>
           </a:p>
         </p:txBody>
@@ -4291,8 +4200,8 @@
         </p:nvSpPr>
         <p:spPr>
           <a:xfrm>
-            <a:off x="2066400" y="9097200"/>
-            <a:ext cx="5349600" cy="439200"/>
+            <a:off x="1893600" y="13924800"/>
+            <a:ext cx="5522400" cy="594000"/>
           </a:xfrm>
           <a:prstGeom prst="rect">
             <a:avLst/>
@@ -4321,36 +4230,17 @@
           </a:fontRef>
         </p:style>
         <p:txBody>
-          <a:bodyPr rtlCol="0" anchor="ctr" wrap="square" lIns="64800" rIns="36000" tIns="36000" bIns="36000"/>
-          <a:lstStyle/>
-          <a:p>
-            <a:pPr algn="ctr">
-              <a:spcAft>
-                <a:spcPts val="100"/>
-              </a:spcAft>
-            </a:pPr>
-            <a:r>
-              <a:rPr sz="600" b="0" i="0">
+          <a:bodyPr rtlCol="0" anchor="ctr" wrap="square" lIns="72000" rIns="36000" tIns="54000" bIns="54000"/>
+          <a:lstStyle/>
+          <a:p>
+            <a:pPr algn="ctr"/>
+            <a:r>
+              <a:rPr sz="2400" b="0" i="0">
                 <a:solidFill>
                   <a:srgbClr val="222222"/>
                 </a:solidFill>
               </a:rPr>
-              <a:t>• Ollama llama3.2 · LangChain ReAct loop</a:t>
-            </a:r>
-          </a:p>
-          <a:p>
-            <a:pPr>
-              <a:spcAft>
-                <a:spcPts val="100"/>
-              </a:spcAft>
-            </a:pPr>
-            <a:r>
-              <a:rPr sz="600" b="0" i="0">
-                <a:solidFill>
-                  <a:srgbClr val="222222"/>
-                </a:solidFill>
-              </a:rPr>
-              <a:t>• 4 domain tool registrations</a:t>
+              <a:t>Annual salary growth, stochastic life events and market dynamics</a:t>
             </a:r>
           </a:p>
         </p:txBody>
@@ -4363,14 +4253,14 @@
         </p:nvSpPr>
         <p:spPr>
           <a:xfrm>
-            <a:off x="432000" y="9550800"/>
-            <a:ext cx="1620000" cy="439200"/>
+            <a:off x="432000" y="14540400"/>
+            <a:ext cx="1440000" cy="594000"/>
           </a:xfrm>
           <a:prstGeom prst="rect">
             <a:avLst/>
           </a:prstGeom>
           <a:solidFill>
-            <a:srgbClr val="1A7A8A"/>
+            <a:srgbClr val="BE1E2D"/>
           </a:solidFill>
           <a:ln w="6350">
             <a:solidFill>
@@ -4393,18 +4283,17 @@
           </a:fontRef>
         </p:style>
         <p:txBody>
-          <a:bodyPr rtlCol="0" anchor="ctr" wrap="square" lIns="43200" rIns="28800" tIns="36000" bIns="36000"/>
+          <a:bodyPr rtlCol="0" anchor="ctr" wrap="square" lIns="54000" rIns="36000" tIns="54000" bIns="54000"/>
           <a:lstStyle/>
           <a:p>
             <a:pPr algn="ctr"/>
             <a:r>
-              <a:rPr sz="600" b="1" i="0">
+              <a:rPr sz="2400" b="1" i="0">
                 <a:solidFill>
                   <a:srgbClr val="FFFFFF"/>
                 </a:solidFill>
               </a:rPr>
-              <a:t>TOOL
-EXECUTION</a:t>
+              <a:t>OUTPUT</a:t>
             </a:r>
           </a:p>
         </p:txBody>
@@ -4417,8 +4306,8 @@
         </p:nvSpPr>
         <p:spPr>
           <a:xfrm>
-            <a:off x="2066400" y="9550800"/>
-            <a:ext cx="5349600" cy="439200"/>
+            <a:off x="1893600" y="14540400"/>
+            <a:ext cx="5522400" cy="594000"/>
           </a:xfrm>
           <a:prstGeom prst="rect">
             <a:avLst/>
@@ -4447,428 +4336,31 @@
           </a:fontRef>
         </p:style>
         <p:txBody>
-          <a:bodyPr rtlCol="0" anchor="ctr" wrap="square" lIns="64800" rIns="36000" tIns="36000" bIns="36000"/>
-          <a:lstStyle/>
-          <a:p>
-            <a:pPr algn="ctr">
-              <a:spcAft>
-                <a:spcPts val="100"/>
-              </a:spcAft>
-            </a:pPr>
-            <a:r>
-              <a:rPr sz="600" b="0" i="0">
+          <a:bodyPr rtlCol="0" anchor="ctr" wrap="square" lIns="72000" rIns="36000" tIns="54000" bIns="54000"/>
+          <a:lstStyle/>
+          <a:p>
+            <a:pPr algn="ctr"/>
+            <a:r>
+              <a:rPr sz="2400" b="0" i="0">
                 <a:solidFill>
                   <a:srgbClr val="222222"/>
                 </a:solidFill>
               </a:rPr>
-              <a:t>• PropertySearch · MortgageCalc</a:t>
-            </a:r>
-          </a:p>
-          <a:p>
-            <a:pPr>
-              <a:spcAft>
-                <a:spcPts val="100"/>
-              </a:spcAft>
-            </a:pPr>
-            <a:r>
-              <a:rPr sz="600" b="0" i="0">
-                <a:solidFill>
-                  <a:srgbClr val="222222"/>
-                </a:solidFill>
-              </a:rPr>
-              <a:t>• AffordabilityCheck · FinancialHealth</a:t>
-            </a:r>
-          </a:p>
-        </p:txBody>
-      </p:sp>
-      <p:sp>
-        <p:nvSpPr>
-          <p:cNvPr id="27" name="Rectangle 26"/>
+              <a:t>Affordability metrics, CSV export and policy scenario analysis</a:t>
+            </a:r>
+          </a:p>
+        </p:txBody>
+      </p:sp>
+      <p:sp>
+        <p:nvSpPr>
+          <p:cNvPr id="27" name="Rounded Rectangle 26"/>
           <p:cNvSpPr/>
           <p:nvPr/>
         </p:nvSpPr>
         <p:spPr>
           <a:xfrm>
-            <a:off x="432000" y="10004400"/>
-            <a:ext cx="1620000" cy="439200"/>
-          </a:xfrm>
-          <a:prstGeom prst="rect">
-            <a:avLst/>
-          </a:prstGeom>
-          <a:solidFill>
-            <a:srgbClr val="A04010"/>
-          </a:solidFill>
-          <a:ln w="6350">
-            <a:solidFill>
-              <a:srgbClr val="FFFFFF"/>
-            </a:solidFill>
-          </a:ln>
-        </p:spPr>
-        <p:style>
-          <a:lnRef idx="1">
-            <a:schemeClr val="accent1"/>
-          </a:lnRef>
-          <a:fillRef idx="3">
-            <a:schemeClr val="accent1"/>
-          </a:fillRef>
-          <a:effectRef idx="2">
-            <a:schemeClr val="accent1"/>
-          </a:effectRef>
-          <a:fontRef idx="minor">
-            <a:schemeClr val="lt1"/>
-          </a:fontRef>
-        </p:style>
-        <p:txBody>
-          <a:bodyPr rtlCol="0" anchor="ctr" wrap="square" lIns="43200" rIns="28800" tIns="36000" bIns="36000"/>
-          <a:lstStyle/>
-          <a:p>
-            <a:pPr algn="ctr"/>
-            <a:r>
-              <a:rPr sz="600" b="1" i="0">
-                <a:solidFill>
-                  <a:srgbClr val="FFFFFF"/>
-                </a:solidFill>
-              </a:rPr>
-              <a:t>ANNUAL
-STEP</a:t>
-            </a:r>
-          </a:p>
-        </p:txBody>
-      </p:sp>
-      <p:sp>
-        <p:nvSpPr>
-          <p:cNvPr id="28" name="Rectangle 27"/>
-          <p:cNvSpPr/>
-          <p:nvPr/>
-        </p:nvSpPr>
-        <p:spPr>
-          <a:xfrm>
-            <a:off x="2066400" y="10004400"/>
-            <a:ext cx="5349600" cy="439200"/>
-          </a:xfrm>
-          <a:prstGeom prst="rect">
-            <a:avLst/>
-          </a:prstGeom>
-          <a:solidFill>
-            <a:srgbClr val="EAF5F7"/>
-          </a:solidFill>
-          <a:ln w="6350">
-            <a:solidFill>
-              <a:srgbClr val="A0D0DA"/>
-            </a:solidFill>
-          </a:ln>
-        </p:spPr>
-        <p:style>
-          <a:lnRef idx="1">
-            <a:schemeClr val="accent1"/>
-          </a:lnRef>
-          <a:fillRef idx="3">
-            <a:schemeClr val="accent1"/>
-          </a:fillRef>
-          <a:effectRef idx="2">
-            <a:schemeClr val="accent1"/>
-          </a:effectRef>
-          <a:fontRef idx="minor">
-            <a:schemeClr val="lt1"/>
-          </a:fontRef>
-        </p:style>
-        <p:txBody>
-          <a:bodyPr rtlCol="0" anchor="ctr" wrap="square" lIns="64800" rIns="36000" tIns="36000" bIns="36000"/>
-          <a:lstStyle/>
-          <a:p>
-            <a:pPr algn="ctr">
-              <a:spcAft>
-                <a:spcPts val="100"/>
-              </a:spcAft>
-            </a:pPr>
-            <a:r>
-              <a:rPr sz="600" b="0" i="0">
-                <a:solidFill>
-                  <a:srgbClr val="222222"/>
-                </a:solidFill>
-              </a:rPr>
-              <a:t>• Salary &amp; expense inflation (2.5%)</a:t>
-            </a:r>
-          </a:p>
-          <a:p>
-            <a:pPr>
-              <a:spcAft>
-                <a:spcPts val="100"/>
-              </a:spcAft>
-            </a:pPr>
-            <a:r>
-              <a:rPr sz="600" b="0" i="0">
-                <a:solidFill>
-                  <a:srgbClr val="222222"/>
-                </a:solidFill>
-              </a:rPr>
-              <a:t>• Stochastic life events · LLM decision</a:t>
-            </a:r>
-          </a:p>
-        </p:txBody>
-      </p:sp>
-      <p:sp>
-        <p:nvSpPr>
-          <p:cNvPr id="29" name="Rectangle 28"/>
-          <p:cNvSpPr/>
-          <p:nvPr/>
-        </p:nvSpPr>
-        <p:spPr>
-          <a:xfrm>
-            <a:off x="432000" y="10458000"/>
-            <a:ext cx="1620000" cy="439200"/>
-          </a:xfrm>
-          <a:prstGeom prst="rect">
-            <a:avLst/>
-          </a:prstGeom>
-          <a:solidFill>
-            <a:srgbClr val="A04010"/>
-          </a:solidFill>
-          <a:ln w="6350">
-            <a:solidFill>
-              <a:srgbClr val="FFFFFF"/>
-            </a:solidFill>
-          </a:ln>
-        </p:spPr>
-        <p:style>
-          <a:lnRef idx="1">
-            <a:schemeClr val="accent1"/>
-          </a:lnRef>
-          <a:fillRef idx="3">
-            <a:schemeClr val="accent1"/>
-          </a:fillRef>
-          <a:effectRef idx="2">
-            <a:schemeClr val="accent1"/>
-          </a:effectRef>
-          <a:fontRef idx="minor">
-            <a:schemeClr val="lt1"/>
-          </a:fontRef>
-        </p:style>
-        <p:txBody>
-          <a:bodyPr rtlCol="0" anchor="ctr" wrap="square" lIns="43200" rIns="28800" tIns="36000" bIns="36000"/>
-          <a:lstStyle/>
-          <a:p>
-            <a:pPr algn="ctr"/>
-            <a:r>
-              <a:rPr sz="600" b="1" i="0">
-                <a:solidFill>
-                  <a:srgbClr val="FFFFFF"/>
-                </a:solidFill>
-              </a:rPr>
-              <a:t>MARKET
-DYNAMICS</a:t>
-            </a:r>
-          </a:p>
-        </p:txBody>
-      </p:sp>
-      <p:sp>
-        <p:nvSpPr>
-          <p:cNvPr id="30" name="Rectangle 29"/>
-          <p:cNvSpPr/>
-          <p:nvPr/>
-        </p:nvSpPr>
-        <p:spPr>
-          <a:xfrm>
-            <a:off x="2066400" y="10458000"/>
-            <a:ext cx="5349600" cy="439200"/>
-          </a:xfrm>
-          <a:prstGeom prst="rect">
-            <a:avLst/>
-          </a:prstGeom>
-          <a:solidFill>
-            <a:srgbClr val="EAF5F7"/>
-          </a:solidFill>
-          <a:ln w="6350">
-            <a:solidFill>
-              <a:srgbClr val="A0D0DA"/>
-            </a:solidFill>
-          </a:ln>
-        </p:spPr>
-        <p:style>
-          <a:lnRef idx="1">
-            <a:schemeClr val="accent1"/>
-          </a:lnRef>
-          <a:fillRef idx="3">
-            <a:schemeClr val="accent1"/>
-          </a:fillRef>
-          <a:effectRef idx="2">
-            <a:schemeClr val="accent1"/>
-          </a:effectRef>
-          <a:fontRef idx="minor">
-            <a:schemeClr val="lt1"/>
-          </a:fontRef>
-        </p:style>
-        <p:txBody>
-          <a:bodyPr rtlCol="0" anchor="ctr" wrap="square" lIns="64800" rIns="36000" tIns="36000" bIns="36000"/>
-          <a:lstStyle/>
-          <a:p>
-            <a:pPr algn="ctr">
-              <a:spcAft>
-                <a:spcPts val="100"/>
-              </a:spcAft>
-            </a:pPr>
-            <a:r>
-              <a:rPr sz="600" b="0" i="0">
-                <a:solidFill>
-                  <a:srgbClr val="222222"/>
-                </a:solidFill>
-              </a:rPr>
-              <a:t>• Regional ONS price growth (2–4% p.a.)</a:t>
-            </a:r>
-          </a:p>
-          <a:p>
-            <a:pPr>
-              <a:spcAft>
-                <a:spcPts val="100"/>
-              </a:spcAft>
-            </a:pPr>
-            <a:r>
-              <a:rPr sz="600" b="0" i="0">
-                <a:solidFill>
-                  <a:srgbClr val="222222"/>
-                </a:solidFill>
-              </a:rPr>
-              <a:t>• Mortgage stress test (+3%) · Logging</a:t>
-            </a:r>
-          </a:p>
-        </p:txBody>
-      </p:sp>
-      <p:sp>
-        <p:nvSpPr>
-          <p:cNvPr id="31" name="Rectangle 30"/>
-          <p:cNvSpPr/>
-          <p:nvPr/>
-        </p:nvSpPr>
-        <p:spPr>
-          <a:xfrm>
-            <a:off x="432000" y="10911600"/>
-            <a:ext cx="1620000" cy="439200"/>
-          </a:xfrm>
-          <a:prstGeom prst="rect">
-            <a:avLst/>
-          </a:prstGeom>
-          <a:solidFill>
-            <a:srgbClr val="BE1E2D"/>
-          </a:solidFill>
-          <a:ln w="6350">
-            <a:solidFill>
-              <a:srgbClr val="FFFFFF"/>
-            </a:solidFill>
-          </a:ln>
-        </p:spPr>
-        <p:style>
-          <a:lnRef idx="1">
-            <a:schemeClr val="accent1"/>
-          </a:lnRef>
-          <a:fillRef idx="3">
-            <a:schemeClr val="accent1"/>
-          </a:fillRef>
-          <a:effectRef idx="2">
-            <a:schemeClr val="accent1"/>
-          </a:effectRef>
-          <a:fontRef idx="minor">
-            <a:schemeClr val="lt1"/>
-          </a:fontRef>
-        </p:style>
-        <p:txBody>
-          <a:bodyPr rtlCol="0" anchor="ctr" wrap="square" lIns="43200" rIns="28800" tIns="36000" bIns="36000"/>
-          <a:lstStyle/>
-          <a:p>
-            <a:pPr algn="ctr"/>
-            <a:r>
-              <a:rPr sz="600" b="1" i="0">
-                <a:solidFill>
-                  <a:srgbClr val="FFFFFF"/>
-                </a:solidFill>
-              </a:rPr>
-              <a:t>OUTPUT
-&amp; ANALYSIS</a:t>
-            </a:r>
-          </a:p>
-        </p:txBody>
-      </p:sp>
-      <p:sp>
-        <p:nvSpPr>
-          <p:cNvPr id="32" name="Rectangle 31"/>
-          <p:cNvSpPr/>
-          <p:nvPr/>
-        </p:nvSpPr>
-        <p:spPr>
-          <a:xfrm>
-            <a:off x="2066400" y="10911600"/>
-            <a:ext cx="5349600" cy="439200"/>
-          </a:xfrm>
-          <a:prstGeom prst="rect">
-            <a:avLst/>
-          </a:prstGeom>
-          <a:solidFill>
-            <a:srgbClr val="EAF5F7"/>
-          </a:solidFill>
-          <a:ln w="6350">
-            <a:solidFill>
-              <a:srgbClr val="A0D0DA"/>
-            </a:solidFill>
-          </a:ln>
-        </p:spPr>
-        <p:style>
-          <a:lnRef idx="1">
-            <a:schemeClr val="accent1"/>
-          </a:lnRef>
-          <a:fillRef idx="3">
-            <a:schemeClr val="accent1"/>
-          </a:fillRef>
-          <a:effectRef idx="2">
-            <a:schemeClr val="accent1"/>
-          </a:effectRef>
-          <a:fontRef idx="minor">
-            <a:schemeClr val="lt1"/>
-          </a:fontRef>
-        </p:style>
-        <p:txBody>
-          <a:bodyPr rtlCol="0" anchor="ctr" wrap="square" lIns="64800" rIns="36000" tIns="36000" bIns="36000"/>
-          <a:lstStyle/>
-          <a:p>
-            <a:pPr algn="ctr">
-              <a:spcAft>
-                <a:spcPts val="100"/>
-              </a:spcAft>
-            </a:pPr>
-            <a:r>
-              <a:rPr sz="600" b="0" i="0">
-                <a:solidFill>
-                  <a:srgbClr val="222222"/>
-                </a:solidFill>
-              </a:rPr>
-              <a:t>• CSV timeline export</a:t>
-            </a:r>
-          </a:p>
-          <a:p>
-            <a:pPr>
-              <a:spcAft>
-                <a:spcPts val="100"/>
-              </a:spcAft>
-            </a:pPr>
-            <a:r>
-              <a:rPr sz="600" b="0" i="0">
-                <a:solidFill>
-                  <a:srgbClr val="222222"/>
-                </a:solidFill>
-              </a:rPr>
-              <a:t>• Affordability metrics · Policy comparisons</a:t>
-            </a:r>
-          </a:p>
-        </p:txBody>
-      </p:sp>
-      <p:sp>
-        <p:nvSpPr>
-          <p:cNvPr id="33" name="Rounded Rectangle 32"/>
-          <p:cNvSpPr/>
-          <p:nvPr/>
-        </p:nvSpPr>
-        <p:spPr>
-          <a:xfrm>
-            <a:off x="432000" y="11509200"/>
-            <a:ext cx="6984000" cy="244800"/>
+            <a:off x="432000" y="15318000"/>
+            <a:ext cx="6984000" cy="468000"/>
           </a:xfrm>
           <a:prstGeom prst="roundRect">
             <a:avLst>
@@ -4897,12 +4389,12 @@
           </a:fontRef>
         </p:style>
         <p:txBody>
-          <a:bodyPr rtlCol="0" anchor="ctr" wrap="square" lIns="79200" rIns="43200" tIns="28800" bIns="28800"/>
+          <a:bodyPr rtlCol="0" anchor="ctr" wrap="square" lIns="79200" rIns="43200" tIns="43200" bIns="43200"/>
           <a:lstStyle/>
           <a:p>
             <a:pPr algn="l"/>
             <a:r>
-              <a:rPr sz="850" b="1" i="0">
+              <a:rPr sz="2600" b="1" i="0">
                 <a:solidFill>
                   <a:srgbClr val="FFFFFF"/>
                 </a:solidFill>
@@ -4914,14 +4406,14 @@
       </p:sp>
       <p:sp>
         <p:nvSpPr>
-          <p:cNvPr id="34" name="TextBox 33"/>
+          <p:cNvPr id="28" name="TextBox 27"/>
           <p:cNvSpPr txBox="1"/>
           <p:nvPr/>
         </p:nvSpPr>
         <p:spPr>
           <a:xfrm>
-            <a:off x="432000" y="11826000"/>
-            <a:ext cx="6984000" cy="1188000"/>
+            <a:off x="432000" y="15876000"/>
+            <a:ext cx="6984000" cy="2520000"/>
           </a:xfrm>
           <a:prstGeom prst="rect">
             <a:avLst/>
@@ -4936,11 +4428,11 @@
           <a:p>
             <a:pPr>
               <a:spcAft>
-                <a:spcPts val="200"/>
+                <a:spcPts val="300"/>
               </a:spcAft>
             </a:pPr>
             <a:r>
-              <a:rPr sz="650" b="1" i="0">
+              <a:rPr sz="2400" b="1" i="0">
                 <a:solidFill>
                   <a:srgbClr val="1A7A8A"/>
                 </a:solidFill>
@@ -4948,22 +4440,22 @@
               <a:t>▸  </a:t>
             </a:r>
             <a:r>
-              <a:rPr sz="650" b="1" i="0">
+              <a:rPr sz="2400" b="1" i="0">
                 <a:solidFill>
                   <a:srgbClr val="222222"/>
                 </a:solidFill>
               </a:rPr>
-              <a:t>HM Land Registry  —  Price Paid Data 2020–2024 (4.2M+ transactions)</a:t>
+              <a:t>Land Registry: 4.2M price transactions, 2020 to 2024</a:t>
             </a:r>
           </a:p>
           <a:p>
             <a:pPr>
               <a:spcAft>
-                <a:spcPts val="200"/>
+                <a:spcPts val="300"/>
               </a:spcAft>
             </a:pPr>
             <a:r>
-              <a:rPr sz="650" b="1" i="0">
+              <a:rPr sz="2400" b="1" i="0">
                 <a:solidFill>
                   <a:srgbClr val="1A7A8A"/>
                 </a:solidFill>
@@ -4971,22 +4463,22 @@
               <a:t>▸  </a:t>
             </a:r>
             <a:r>
-              <a:rPr sz="650" b="0" i="0">
+              <a:rPr sz="2400" b="0" i="0">
                 <a:solidFill>
                   <a:srgbClr val="222222"/>
                 </a:solidFill>
               </a:rPr>
-              <a:t>ONS Income Survey  —  Household income percentiles, age &amp; region (2022/23)</a:t>
+              <a:t>ONS: household income by age and region</a:t>
             </a:r>
           </a:p>
           <a:p>
             <a:pPr>
               <a:spcAft>
-                <a:spcPts val="200"/>
+                <a:spcPts val="300"/>
               </a:spcAft>
             </a:pPr>
             <a:r>
-              <a:rPr sz="650" b="1" i="0">
+              <a:rPr sz="2400" b="1" i="0">
                 <a:solidFill>
                   <a:srgbClr val="1A7A8A"/>
                 </a:solidFill>
@@ -4994,22 +4486,22 @@
               <a:t>▸  </a:t>
             </a:r>
             <a:r>
-              <a:rPr sz="650" b="0" i="0">
+              <a:rPr sz="2400" b="0" i="0">
                 <a:solidFill>
                   <a:srgbClr val="222222"/>
                 </a:solidFill>
               </a:rPr>
-              <a:t>Bank of England  —  Base rate history &amp; mortgage affordability guidelines</a:t>
+              <a:t>Bank of England: base rates and mortgage data</a:t>
             </a:r>
           </a:p>
           <a:p>
             <a:pPr>
               <a:spcAft>
-                <a:spcPts val="200"/>
+                <a:spcPts val="300"/>
               </a:spcAft>
             </a:pPr>
             <a:r>
-              <a:rPr sz="650" b="1" i="0">
+              <a:rPr sz="2400" b="1" i="0">
                 <a:solidFill>
                   <a:srgbClr val="1A7A8A"/>
                 </a:solidFill>
@@ -5017,22 +4509,22 @@
               <a:t>▸  </a:t>
             </a:r>
             <a:r>
-              <a:rPr sz="650" b="0" i="0">
+              <a:rPr sz="2400" b="0" i="0">
                 <a:solidFill>
                   <a:srgbClr val="222222"/>
                 </a:solidFill>
               </a:rPr>
-              <a:t>ONS UK HPI  —  Regional annual house price growth rates &amp; indices</a:t>
+              <a:t>ONS UK HPI: regional annual price growth rates</a:t>
             </a:r>
           </a:p>
           <a:p>
             <a:pPr>
               <a:spcAft>
-                <a:spcPts val="200"/>
+                <a:spcPts val="300"/>
               </a:spcAft>
             </a:pPr>
             <a:r>
-              <a:rPr sz="650" b="1" i="0">
+              <a:rPr sz="2400" b="1" i="0">
                 <a:solidFill>
                   <a:srgbClr val="1A7A8A"/>
                 </a:solidFill>
@@ -5040,26 +4532,26 @@
               <a:t>▸  </a:t>
             </a:r>
             <a:r>
-              <a:rPr sz="650" b="0" i="0">
+              <a:rPr sz="2400" b="0" i="0">
                 <a:solidFill>
                   <a:srgbClr val="222222"/>
                 </a:solidFill>
               </a:rPr>
-              <a:t>HMRC / SDLT  —  Stamp duty thresholds &amp; first-time buyer relief bands</a:t>
-            </a:r>
-          </a:p>
-        </p:txBody>
-      </p:sp>
-      <p:sp>
-        <p:nvSpPr>
-          <p:cNvPr id="35" name="Rounded Rectangle 34"/>
+              <a:t>HMRC/SDLT: stamp duty and first-time buyer relief</a:t>
+            </a:r>
+          </a:p>
+        </p:txBody>
+      </p:sp>
+      <p:sp>
+        <p:nvSpPr>
+          <p:cNvPr id="29" name="Rounded Rectangle 28"/>
           <p:cNvSpPr/>
           <p:nvPr/>
         </p:nvSpPr>
         <p:spPr>
           <a:xfrm>
-            <a:off x="432000" y="13140000"/>
-            <a:ext cx="6984000" cy="244800"/>
+            <a:off x="432000" y="18558000"/>
+            <a:ext cx="6984000" cy="468000"/>
           </a:xfrm>
           <a:prstGeom prst="roundRect">
             <a:avLst>
@@ -5088,12 +4580,12 @@
           </a:fontRef>
         </p:style>
         <p:txBody>
-          <a:bodyPr rtlCol="0" anchor="ctr" wrap="square" lIns="79200" rIns="43200" tIns="28800" bIns="28800"/>
+          <a:bodyPr rtlCol="0" anchor="ctr" wrap="square" lIns="79200" rIns="43200" tIns="43200" bIns="43200"/>
           <a:lstStyle/>
           <a:p>
             <a:pPr algn="l"/>
             <a:r>
-              <a:rPr sz="850" b="1" i="0">
+              <a:rPr sz="2600" b="1" i="0">
                 <a:solidFill>
                   <a:srgbClr val="FFFFFF"/>
                 </a:solidFill>
@@ -5105,14 +4597,14 @@
       </p:sp>
       <p:sp>
         <p:nvSpPr>
-          <p:cNvPr id="36" name="TextBox 35"/>
+          <p:cNvPr id="30" name="TextBox 29"/>
           <p:cNvSpPr txBox="1"/>
           <p:nvPr/>
         </p:nvSpPr>
         <p:spPr>
           <a:xfrm>
-            <a:off x="432000" y="13456800"/>
-            <a:ext cx="6984000" cy="1440000"/>
+            <a:off x="432000" y="19116000"/>
+            <a:ext cx="6984000" cy="2160000"/>
           </a:xfrm>
           <a:prstGeom prst="rect">
             <a:avLst/>
@@ -5127,11 +4619,11 @@
           <a:p>
             <a:pPr>
               <a:spcAft>
-                <a:spcPts val="200"/>
+                <a:spcPts val="300"/>
               </a:spcAft>
             </a:pPr>
             <a:r>
-              <a:rPr sz="650" b="1" i="0">
+              <a:rPr sz="2400" b="1" i="0">
                 <a:solidFill>
                   <a:srgbClr val="1A7A8A"/>
                 </a:solidFill>
@@ -5139,22 +4631,22 @@
               <a:t>▸  </a:t>
             </a:r>
             <a:r>
-              <a:rPr sz="650" b="0" i="0">
+              <a:rPr sz="2400" b="0" i="0">
                 <a:solidFill>
                   <a:srgbClr val="222222"/>
                 </a:solidFill>
               </a:rPr>
-              <a:t>LLM Engine  —  Ollama llama3.2 (local inference, zero data leakage)</a:t>
+              <a:t>LLM Engine: Ollama llama3.2, local inference</a:t>
             </a:r>
           </a:p>
           <a:p>
             <a:pPr>
               <a:spcAft>
-                <a:spcPts val="200"/>
+                <a:spcPts val="300"/>
               </a:spcAft>
             </a:pPr>
             <a:r>
-              <a:rPr sz="650" b="1" i="0">
+              <a:rPr sz="2400" b="1" i="0">
                 <a:solidFill>
                   <a:srgbClr val="1A7A8A"/>
                 </a:solidFill>
@@ -5162,22 +4654,22 @@
               <a:t>▸  </a:t>
             </a:r>
             <a:r>
-              <a:rPr sz="650" b="0" i="0">
+              <a:rPr sz="2400" b="0" i="0">
                 <a:solidFill>
                   <a:srgbClr val="222222"/>
                 </a:solidFill>
               </a:rPr>
-              <a:t>Agent Framework  —  LangChain ReAct with 4 specialist domain tools</a:t>
+              <a:t>LangChain ReAct with 4 specialist domain tools</a:t>
             </a:r>
           </a:p>
           <a:p>
             <a:pPr>
               <a:spcAft>
-                <a:spcPts val="200"/>
+                <a:spcPts val="300"/>
               </a:spcAft>
             </a:pPr>
             <a:r>
-              <a:rPr sz="650" b="1" i="0">
+              <a:rPr sz="2400" b="1" i="0">
                 <a:solidFill>
                   <a:srgbClr val="1A7A8A"/>
                 </a:solidFill>
@@ -5185,22 +4677,22 @@
               <a:t>▸  </a:t>
             </a:r>
             <a:r>
-              <a:rPr sz="650" b="0" i="0">
+              <a:rPr sz="2400" b="0" i="0">
                 <a:solidFill>
                   <a:srgbClr val="222222"/>
                 </a:solidFill>
               </a:rPr>
-              <a:t>Housing Data  —  Pandas + NumPy · fuzzy-match over 4.2M+ records</a:t>
+              <a:t>Pandas and NumPy over 4.2M+ housing records</a:t>
             </a:r>
           </a:p>
           <a:p>
             <a:pPr>
               <a:spcAft>
-                <a:spcPts val="200"/>
+                <a:spcPts val="300"/>
               </a:spcAft>
             </a:pPr>
             <a:r>
-              <a:rPr sz="650" b="1" i="0">
+              <a:rPr sz="2400" b="1" i="0">
                 <a:solidFill>
                   <a:srgbClr val="1A7A8A"/>
                 </a:solidFill>
@@ -5208,95 +4700,26 @@
               <a:t>▸  </a:t>
             </a:r>
             <a:r>
-              <a:rPr sz="650" b="0" i="0">
+              <a:rPr sz="2400" b="0" i="0">
                 <a:solidFill>
                   <a:srgbClr val="222222"/>
                 </a:solidFill>
               </a:rPr>
-              <a:t>Financial Layer  —  SalaryCalculator, MortgageProduct, ExpenseManager</a:t>
-            </a:r>
-          </a:p>
-          <a:p>
-            <a:pPr>
-              <a:spcAft>
-                <a:spcPts val="200"/>
-              </a:spcAft>
-            </a:pPr>
-            <a:r>
-              <a:rPr sz="650" b="1" i="0">
-                <a:solidFill>
-                  <a:srgbClr val="1A7A8A"/>
-                </a:solidFill>
-              </a:rPr>
-              <a:t>▸  </a:t>
-            </a:r>
-            <a:r>
-              <a:rPr sz="650" b="0" i="0">
-                <a:solidFill>
-                  <a:srgbClr val="222222"/>
-                </a:solidFill>
-              </a:rPr>
-              <a:t>Algorithms  —  HousingPreferenceEvaluator, FinancialAffordabilityEvaluator</a:t>
-            </a:r>
-          </a:p>
-          <a:p>
-            <a:pPr>
-              <a:spcAft>
-                <a:spcPts val="200"/>
-              </a:spcAft>
-            </a:pPr>
-            <a:r>
-              <a:rPr sz="650" b="1" i="0">
-                <a:solidFill>
-                  <a:srgbClr val="1A7A8A"/>
-                </a:solidFill>
-              </a:rPr>
-              <a:t>▸  </a:t>
-            </a:r>
-            <a:r>
-              <a:rPr sz="650" b="0" i="0">
-                <a:solidFill>
-                  <a:srgbClr val="222222"/>
-                </a:solidFill>
-              </a:rPr>
-              <a:t>Well-being  —  HappinessEvaluator (composite scoring 0–100)</a:t>
-            </a:r>
-          </a:p>
-          <a:p>
-            <a:pPr>
-              <a:spcAft>
-                <a:spcPts val="200"/>
-              </a:spcAft>
-            </a:pPr>
-            <a:r>
-              <a:rPr sz="650" b="1" i="0">
-                <a:solidFill>
-                  <a:srgbClr val="1A7A8A"/>
-                </a:solidFill>
-              </a:rPr>
-              <a:t>▸  </a:t>
-            </a:r>
-            <a:r>
-              <a:rPr sz="650" b="0" i="0">
-                <a:solidFill>
-                  <a:srgbClr val="222222"/>
-                </a:solidFill>
-              </a:rPr>
-              <a:t>Output  —  SimulationLogger → CSV timeline; matplotlib charts</a:t>
-            </a:r>
-          </a:p>
-        </p:txBody>
-      </p:sp>
-      <p:sp>
-        <p:nvSpPr>
-          <p:cNvPr id="37" name="Rounded Rectangle 36"/>
+              <a:t>Output: SimulationLogger, CSV and matplotlib charts</a:t>
+            </a:r>
+          </a:p>
+        </p:txBody>
+      </p:sp>
+      <p:sp>
+        <p:nvSpPr>
+          <p:cNvPr id="31" name="Rounded Rectangle 30"/>
           <p:cNvSpPr/>
           <p:nvPr/>
         </p:nvSpPr>
         <p:spPr>
           <a:xfrm>
-            <a:off x="7704000" y="2772000"/>
-            <a:ext cx="6984000" cy="244800"/>
+            <a:off x="7704000" y="3348000"/>
+            <a:ext cx="6984000" cy="468000"/>
           </a:xfrm>
           <a:prstGeom prst="roundRect">
             <a:avLst>
@@ -5325,414 +4748,12 @@
           </a:fontRef>
         </p:style>
         <p:txBody>
-          <a:bodyPr rtlCol="0" anchor="ctr" wrap="square" lIns="79200" rIns="43200" tIns="28800" bIns="28800"/>
+          <a:bodyPr rtlCol="0" anchor="ctr" wrap="square" lIns="79200" rIns="43200" tIns="43200" bIns="43200"/>
           <a:lstStyle/>
           <a:p>
             <a:pPr algn="l"/>
             <a:r>
-              <a:rPr sz="850" b="1" i="0">
-                <a:solidFill>
-                  <a:srgbClr val="FFFFFF"/>
-                </a:solidFill>
-              </a:rPr>
-              <a:t>AGENT ARCHITECTURE &amp; DECISION MODEL</a:t>
-            </a:r>
-          </a:p>
-        </p:txBody>
-      </p:sp>
-      <p:sp>
-        <p:nvSpPr>
-          <p:cNvPr id="38" name="TextBox 37"/>
-          <p:cNvSpPr txBox="1"/>
-          <p:nvPr/>
-        </p:nvSpPr>
-        <p:spPr>
-          <a:xfrm>
-            <a:off x="7704000" y="3088800"/>
-            <a:ext cx="6984000" cy="162000"/>
-          </a:xfrm>
-          <a:prstGeom prst="rect">
-            <a:avLst/>
-          </a:prstGeom>
-          <a:noFill/>
-        </p:spPr>
-        <p:txBody>
-          <a:bodyPr wrap="none">
-            <a:spAutoFit/>
-          </a:bodyPr>
-          <a:lstStyle/>
-          <a:p>
-            <a:r>
-              <a:rPr sz="750" b="1" i="0">
-                <a:solidFill>
-                  <a:srgbClr val="1A7A8A"/>
-                </a:solidFill>
-              </a:rPr>
-              <a:t>ReAct Decision Loop</a:t>
-            </a:r>
-          </a:p>
-        </p:txBody>
-      </p:sp>
-      <p:sp>
-        <p:nvSpPr>
-          <p:cNvPr id="39" name="TextBox 38"/>
-          <p:cNvSpPr txBox="1"/>
-          <p:nvPr/>
-        </p:nvSpPr>
-        <p:spPr>
-          <a:xfrm>
-            <a:off x="7704000" y="3293999"/>
-            <a:ext cx="6984000" cy="503999"/>
-          </a:xfrm>
-          <a:prstGeom prst="rect">
-            <a:avLst/>
-          </a:prstGeom>
-          <a:noFill/>
-        </p:spPr>
-        <p:txBody>
-          <a:bodyPr wrap="square" lIns="0" rIns="0" tIns="0" bIns="0">
-            <a:spAutoFit/>
-          </a:bodyPr>
-          <a:lstStyle/>
-          <a:p>
-            <a:pPr>
-              <a:spcAft>
-                <a:spcPts val="200"/>
-              </a:spcAft>
-            </a:pPr>
-            <a:r>
-              <a:rPr sz="650" b="0" i="0">
-                <a:solidFill>
-                  <a:srgbClr val="222222"/>
-                </a:solidFill>
-              </a:rPr>
-              <a:t>Each agent runs a Reason + Act (ReAct) cycle: the LLM reviews its current financial state, invokes specialist domain tools for calculations, then synthesises a contextually grounded housing decision. This loop repeats each annual time-step across the 10-year simulation horizon.</a:t>
-            </a:r>
-          </a:p>
-        </p:txBody>
-      </p:sp>
-      <p:sp>
-        <p:nvSpPr>
-          <p:cNvPr id="40" name="TextBox 39"/>
-          <p:cNvSpPr txBox="1"/>
-          <p:nvPr/>
-        </p:nvSpPr>
-        <p:spPr>
-          <a:xfrm>
-            <a:off x="7704000" y="3833999"/>
-            <a:ext cx="6984000" cy="936000"/>
-          </a:xfrm>
-          <a:prstGeom prst="rect">
-            <a:avLst/>
-          </a:prstGeom>
-          <a:noFill/>
-        </p:spPr>
-        <p:txBody>
-          <a:bodyPr wrap="square" lIns="0" rIns="0" tIns="0" bIns="0">
-            <a:spAutoFit/>
-          </a:bodyPr>
-          <a:lstStyle/>
-          <a:p>
-            <a:pPr>
-              <a:spcAft>
-                <a:spcPts val="200"/>
-              </a:spcAft>
-            </a:pPr>
-            <a:r>
-              <a:rPr sz="650" b="1" i="0">
-                <a:solidFill>
-                  <a:srgbClr val="1A7A8A"/>
-                </a:solidFill>
-              </a:rPr>
-              <a:t>→  </a:t>
-            </a:r>
-            <a:r>
-              <a:rPr sz="650" b="0" i="0">
-                <a:solidFill>
-                  <a:srgbClr val="222222"/>
-                </a:solidFill>
-              </a:rPr>
-              <a:t>PropertySearchTool — fuzzy search of Land Registry records by region, type &amp; budget</a:t>
-            </a:r>
-          </a:p>
-          <a:p>
-            <a:pPr>
-              <a:spcAft>
-                <a:spcPts val="200"/>
-              </a:spcAft>
-            </a:pPr>
-            <a:r>
-              <a:rPr sz="650" b="1" i="0">
-                <a:solidFill>
-                  <a:srgbClr val="1A7A8A"/>
-                </a:solidFill>
-              </a:rPr>
-              <a:t>→  </a:t>
-            </a:r>
-            <a:r>
-              <a:rPr sz="650" b="0" i="0">
-                <a:solidFill>
-                  <a:srgbClr val="222222"/>
-                </a:solidFill>
-              </a:rPr>
-              <a:t>MortgageCalculatorTool — LTV ratios, monthly payments, stress tests (base rate + 3%)</a:t>
-            </a:r>
-          </a:p>
-          <a:p>
-            <a:pPr>
-              <a:spcAft>
-                <a:spcPts val="200"/>
-              </a:spcAft>
-            </a:pPr>
-            <a:r>
-              <a:rPr sz="650" b="1" i="0">
-                <a:solidFill>
-                  <a:srgbClr val="1A7A8A"/>
-                </a:solidFill>
-              </a:rPr>
-              <a:t>→  </a:t>
-            </a:r>
-            <a:r>
-              <a:rPr sz="650" b="0" i="0">
-                <a:solidFill>
-                  <a:srgbClr val="222222"/>
-                </a:solidFill>
-              </a:rPr>
-              <a:t>AffordabilityAssessmentTool — income percentile, deposit readiness, price/income ratio</a:t>
-            </a:r>
-          </a:p>
-          <a:p>
-            <a:pPr>
-              <a:spcAft>
-                <a:spcPts val="200"/>
-              </a:spcAft>
-            </a:pPr>
-            <a:r>
-              <a:rPr sz="650" b="1" i="0">
-                <a:solidFill>
-                  <a:srgbClr val="1A7A8A"/>
-                </a:solidFill>
-              </a:rPr>
-              <a:t>→  </a:t>
-            </a:r>
-            <a:r>
-              <a:rPr sz="650" b="0" i="0">
-                <a:solidFill>
-                  <a:srgbClr val="222222"/>
-                </a:solidFill>
-              </a:rPr>
-              <a:t>FinancialHealthTool — savings trajectory, debt obligations, monthly disposable income</a:t>
-            </a:r>
-          </a:p>
-        </p:txBody>
-      </p:sp>
-      <p:sp>
-        <p:nvSpPr>
-          <p:cNvPr id="41" name="TextBox 40"/>
-          <p:cNvSpPr txBox="1"/>
-          <p:nvPr/>
-        </p:nvSpPr>
-        <p:spPr>
-          <a:xfrm>
-            <a:off x="7704000" y="4895999"/>
-            <a:ext cx="6984000" cy="162000"/>
-          </a:xfrm>
-          <a:prstGeom prst="rect">
-            <a:avLst/>
-          </a:prstGeom>
-          <a:noFill/>
-        </p:spPr>
-        <p:txBody>
-          <a:bodyPr wrap="none">
-            <a:spAutoFit/>
-          </a:bodyPr>
-          <a:lstStyle/>
-          <a:p>
-            <a:r>
-              <a:rPr sz="750" b="1" i="0">
-                <a:solidFill>
-                  <a:srgbClr val="1A7A8A"/>
-                </a:solidFill>
-              </a:rPr>
-              <a:t>Stochastic Life Events</a:t>
-            </a:r>
-          </a:p>
-        </p:txBody>
-      </p:sp>
-      <p:sp>
-        <p:nvSpPr>
-          <p:cNvPr id="42" name="TextBox 41"/>
-          <p:cNvSpPr txBox="1"/>
-          <p:nvPr/>
-        </p:nvSpPr>
-        <p:spPr>
-          <a:xfrm>
-            <a:off x="7704000" y="5101199"/>
-            <a:ext cx="6984000" cy="360000"/>
-          </a:xfrm>
-          <a:prstGeom prst="rect">
-            <a:avLst/>
-          </a:prstGeom>
-          <a:noFill/>
-        </p:spPr>
-        <p:txBody>
-          <a:bodyPr wrap="square" lIns="0" rIns="0" tIns="0" bIns="0">
-            <a:spAutoFit/>
-          </a:bodyPr>
-          <a:lstStyle/>
-          <a:p>
-            <a:pPr>
-              <a:spcAft>
-                <a:spcPts val="200"/>
-              </a:spcAft>
-            </a:pPr>
-            <a:r>
-              <a:rPr sz="650" b="0" i="0">
-                <a:solidFill>
-                  <a:srgbClr val="222222"/>
-                </a:solidFill>
-              </a:rPr>
-              <a:t>Each year agents may experience life events drawn from age-weighted probability distributions, directly influencing financial capacity and housing need.</a:t>
-            </a:r>
-          </a:p>
-        </p:txBody>
-      </p:sp>
-      <p:sp>
-        <p:nvSpPr>
-          <p:cNvPr id="43" name="TextBox 42"/>
-          <p:cNvSpPr txBox="1"/>
-          <p:nvPr/>
-        </p:nvSpPr>
-        <p:spPr>
-          <a:xfrm>
-            <a:off x="7704000" y="5461199"/>
-            <a:ext cx="6984000" cy="648000"/>
-          </a:xfrm>
-          <a:prstGeom prst="rect">
-            <a:avLst/>
-          </a:prstGeom>
-          <a:noFill/>
-        </p:spPr>
-        <p:txBody>
-          <a:bodyPr wrap="square" lIns="0" rIns="0" tIns="0" bIns="0">
-            <a:spAutoFit/>
-          </a:bodyPr>
-          <a:lstStyle/>
-          <a:p>
-            <a:pPr>
-              <a:spcAft>
-                <a:spcPts val="200"/>
-              </a:spcAft>
-            </a:pPr>
-            <a:r>
-              <a:rPr sz="650" b="1" i="0">
-                <a:solidFill>
-                  <a:srgbClr val="1A7A8A"/>
-                </a:solidFill>
-              </a:rPr>
-              <a:t>•  </a:t>
-            </a:r>
-            <a:r>
-              <a:rPr sz="650" b="0" i="0">
-                <a:solidFill>
-                  <a:srgbClr val="222222"/>
-                </a:solidFill>
-              </a:rPr>
-              <a:t>Salary increase (15% prob., age 18–29);  job promotion (8–10%)</a:t>
-            </a:r>
-          </a:p>
-          <a:p>
-            <a:pPr>
-              <a:spcAft>
-                <a:spcPts val="200"/>
-              </a:spcAft>
-            </a:pPr>
-            <a:r>
-              <a:rPr sz="650" b="1" i="0">
-                <a:solidFill>
-                  <a:srgbClr val="1A7A8A"/>
-                </a:solidFill>
-              </a:rPr>
-              <a:t>•  </a:t>
-            </a:r>
-            <a:r>
-              <a:rPr sz="650" b="0" i="0">
-                <a:solidFill>
-                  <a:srgbClr val="222222"/>
-                </a:solidFill>
-              </a:rPr>
-              <a:t>Job loss (2–4%);  marriage (5–8%);  birth of child (3–10%)</a:t>
-            </a:r>
-          </a:p>
-          <a:p>
-            <a:pPr>
-              <a:spcAft>
-                <a:spcPts val="200"/>
-              </a:spcAft>
-            </a:pPr>
-            <a:r>
-              <a:rPr sz="650" b="1" i="0">
-                <a:solidFill>
-                  <a:srgbClr val="1A7A8A"/>
-                </a:solidFill>
-              </a:rPr>
-              <a:t>•  </a:t>
-            </a:r>
-            <a:r>
-              <a:rPr sz="650" b="0" i="0">
-                <a:solidFill>
-                  <a:srgbClr val="222222"/>
-                </a:solidFill>
-              </a:rPr>
-              <a:t>Divorce (1–3%);  bereavement;  serious illness;  debt increase</a:t>
-            </a:r>
-          </a:p>
-        </p:txBody>
-      </p:sp>
-      <p:sp>
-        <p:nvSpPr>
-          <p:cNvPr id="44" name="Rounded Rectangle 43"/>
-          <p:cNvSpPr/>
-          <p:nvPr/>
-        </p:nvSpPr>
-        <p:spPr>
-          <a:xfrm>
-            <a:off x="7704000" y="6253199"/>
-            <a:ext cx="6984000" cy="244800"/>
-          </a:xfrm>
-          <a:prstGeom prst="roundRect">
-            <a:avLst>
-              <a:gd name="adj" fmla="val 30000"/>
-            </a:avLst>
-          </a:prstGeom>
-          <a:solidFill>
-            <a:srgbClr val="1A7A8A"/>
-          </a:solidFill>
-          <a:ln>
-            <a:noFill/>
-          </a:ln>
-        </p:spPr>
-        <p:style>
-          <a:lnRef idx="1">
-            <a:schemeClr val="accent1"/>
-          </a:lnRef>
-          <a:fillRef idx="3">
-            <a:schemeClr val="accent1"/>
-          </a:fillRef>
-          <a:effectRef idx="2">
-            <a:schemeClr val="accent1"/>
-          </a:effectRef>
-          <a:fontRef idx="minor">
-            <a:schemeClr val="lt1"/>
-          </a:fontRef>
-        </p:style>
-        <p:txBody>
-          <a:bodyPr rtlCol="0" anchor="ctr" wrap="square" lIns="79200" rIns="43200" tIns="28800" bIns="28800"/>
-          <a:lstStyle/>
-          <a:p>
-            <a:pPr algn="l"/>
-            <a:r>
-              <a:rPr sz="850" b="1" i="0">
+              <a:rPr sz="2600" b="1" i="0">
                 <a:solidFill>
                   <a:srgbClr val="FFFFFF"/>
                 </a:solidFill>
@@ -5744,7 +4765,7 @@
       </p:sp>
       <p:pic>
         <p:nvPicPr>
-          <p:cNvPr id="45" name="Picture 44" descr="image.png"/>
+          <p:cNvPr id="32" name="Picture 31" descr="image.png"/>
           <p:cNvPicPr>
             <a:picLocks noChangeAspect="1"/>
           </p:cNvPicPr>
@@ -5758,8 +4779,8 @@
         </p:blipFill>
         <p:spPr>
           <a:xfrm>
-            <a:off x="7704000" y="6569999"/>
-            <a:ext cx="3447000" cy="2163975"/>
+            <a:off x="7704000" y="3906000"/>
+            <a:ext cx="3438000" cy="2253971"/>
           </a:xfrm>
           <a:prstGeom prst="rect">
             <a:avLst/>
@@ -5768,7 +4789,7 @@
       </p:pic>
       <p:pic>
         <p:nvPicPr>
-          <p:cNvPr id="46" name="Picture 45" descr="image.png"/>
+          <p:cNvPr id="33" name="Picture 32" descr="image.png"/>
           <p:cNvPicPr>
             <a:picLocks noChangeAspect="1"/>
           </p:cNvPicPr>
@@ -5782,8 +4803,8 @@
         </p:blipFill>
         <p:spPr>
           <a:xfrm>
-            <a:off x="11241000" y="6569999"/>
-            <a:ext cx="3447000" cy="1963252"/>
+            <a:off x="11250000" y="3906000"/>
+            <a:ext cx="3438000" cy="2129023"/>
           </a:xfrm>
           <a:prstGeom prst="rect">
             <a:avLst/>
@@ -5792,14 +4813,14 @@
       </p:pic>
       <p:sp>
         <p:nvSpPr>
-          <p:cNvPr id="47" name="Rounded Rectangle 46"/>
+          <p:cNvPr id="34" name="Rounded Rectangle 33"/>
           <p:cNvSpPr/>
           <p:nvPr/>
         </p:nvSpPr>
         <p:spPr>
           <a:xfrm>
-            <a:off x="7704000" y="8805974"/>
-            <a:ext cx="1713600" cy="486000"/>
+            <a:off x="7704000" y="6231971"/>
+            <a:ext cx="1705500" cy="864000"/>
           </a:xfrm>
           <a:prstGeom prst="roundRect">
             <a:avLst>
@@ -5830,12 +4851,12 @@
           </a:fontRef>
         </p:style>
         <p:txBody>
-          <a:bodyPr rtlCol="0" anchor="ctr" wrap="square" lIns="43200" rIns="43200" tIns="43200" bIns="28800"/>
+          <a:bodyPr rtlCol="0" anchor="ctr" wrap="square" lIns="43200" rIns="43200" tIns="64800" bIns="36000"/>
           <a:lstStyle/>
           <a:p>
             <a:pPr algn="ctr"/>
             <a:r>
-              <a:rPr sz="800" b="1" i="0">
+              <a:rPr sz="2800" b="1" i="0">
                 <a:solidFill>
                   <a:srgbClr val="1A7A8A"/>
                 </a:solidFill>
@@ -5846,11 +4867,11 @@
           <a:p>
             <a:pPr algn="ctr">
               <a:spcBef>
-                <a:spcPts val="200"/>
+                <a:spcPts val="400"/>
               </a:spcBef>
             </a:pPr>
             <a:r>
-              <a:rPr sz="600" b="0" i="0">
+              <a:rPr sz="2400" b="0" i="0">
                 <a:solidFill>
                   <a:srgbClr val="222222"/>
                 </a:solidFill>
@@ -5863,14 +4884,14 @@
       </p:sp>
       <p:sp>
         <p:nvSpPr>
-          <p:cNvPr id="48" name="Rounded Rectangle 47"/>
+          <p:cNvPr id="35" name="Rounded Rectangle 34"/>
           <p:cNvSpPr/>
           <p:nvPr/>
         </p:nvSpPr>
         <p:spPr>
           <a:xfrm>
-            <a:off x="9460800" y="8805974"/>
-            <a:ext cx="1713600" cy="486000"/>
+            <a:off x="9463500" y="6231971"/>
+            <a:ext cx="1705500" cy="864000"/>
           </a:xfrm>
           <a:prstGeom prst="roundRect">
             <a:avLst>
@@ -5901,12 +4922,12 @@
           </a:fontRef>
         </p:style>
         <p:txBody>
-          <a:bodyPr rtlCol="0" anchor="ctr" wrap="square" lIns="43200" rIns="43200" tIns="43200" bIns="28800"/>
+          <a:bodyPr rtlCol="0" anchor="ctr" wrap="square" lIns="43200" rIns="43200" tIns="64800" bIns="36000"/>
           <a:lstStyle/>
           <a:p>
             <a:pPr algn="ctr"/>
             <a:r>
-              <a:rPr sz="800" b="1" i="0">
+              <a:rPr sz="2800" b="1" i="0">
                 <a:solidFill>
                   <a:srgbClr val="1A7A8A"/>
                 </a:solidFill>
@@ -5917,11 +4938,11 @@
           <a:p>
             <a:pPr algn="ctr">
               <a:spcBef>
-                <a:spcPts val="200"/>
+                <a:spcPts val="400"/>
               </a:spcBef>
             </a:pPr>
             <a:r>
-              <a:rPr sz="600" b="0" i="0">
+              <a:rPr sz="2400" b="0" i="0">
                 <a:solidFill>
                   <a:srgbClr val="222222"/>
                 </a:solidFill>
@@ -5934,14 +4955,14 @@
       </p:sp>
       <p:sp>
         <p:nvSpPr>
-          <p:cNvPr id="49" name="Rounded Rectangle 48"/>
+          <p:cNvPr id="36" name="Rounded Rectangle 35"/>
           <p:cNvSpPr/>
           <p:nvPr/>
         </p:nvSpPr>
         <p:spPr>
           <a:xfrm>
-            <a:off x="11217600" y="8805974"/>
-            <a:ext cx="1713600" cy="486000"/>
+            <a:off x="11223000" y="6231971"/>
+            <a:ext cx="1705500" cy="864000"/>
           </a:xfrm>
           <a:prstGeom prst="roundRect">
             <a:avLst>
@@ -5972,12 +4993,12 @@
           </a:fontRef>
         </p:style>
         <p:txBody>
-          <a:bodyPr rtlCol="0" anchor="ctr" wrap="square" lIns="43200" rIns="43200" tIns="43200" bIns="28800"/>
+          <a:bodyPr rtlCol="0" anchor="ctr" wrap="square" lIns="43200" rIns="43200" tIns="64800" bIns="36000"/>
           <a:lstStyle/>
           <a:p>
             <a:pPr algn="ctr"/>
             <a:r>
-              <a:rPr sz="800" b="1" i="0">
+              <a:rPr sz="2800" b="1" i="0">
                 <a:solidFill>
                   <a:srgbClr val="1A7A8A"/>
                 </a:solidFill>
@@ -5988,31 +5009,31 @@
           <a:p>
             <a:pPr algn="ctr">
               <a:spcBef>
-                <a:spcPts val="200"/>
+                <a:spcPts val="400"/>
               </a:spcBef>
             </a:pPr>
             <a:r>
-              <a:rPr sz="600" b="0" i="0">
+              <a:rPr sz="2400" b="0" i="0">
                 <a:solidFill>
                   <a:srgbClr val="222222"/>
                 </a:solidFill>
               </a:rPr>
               <a:t>Avg deposit
-% of price</a:t>
-            </a:r>
-          </a:p>
-        </p:txBody>
-      </p:sp>
-      <p:sp>
-        <p:nvSpPr>
-          <p:cNvPr id="50" name="Rounded Rectangle 49"/>
+as % of price</a:t>
+            </a:r>
+          </a:p>
+        </p:txBody>
+      </p:sp>
+      <p:sp>
+        <p:nvSpPr>
+          <p:cNvPr id="37" name="Rounded Rectangle 36"/>
           <p:cNvSpPr/>
           <p:nvPr/>
         </p:nvSpPr>
         <p:spPr>
           <a:xfrm>
-            <a:off x="12974400" y="8805974"/>
-            <a:ext cx="1713600" cy="486000"/>
+            <a:off x="12982500" y="6231971"/>
+            <a:ext cx="1705500" cy="864000"/>
           </a:xfrm>
           <a:prstGeom prst="roundRect">
             <a:avLst>
@@ -6043,47 +5064,47 @@
           </a:fontRef>
         </p:style>
         <p:txBody>
-          <a:bodyPr rtlCol="0" anchor="ctr" wrap="square" lIns="43200" rIns="43200" tIns="43200" bIns="28800"/>
+          <a:bodyPr rtlCol="0" anchor="ctr" wrap="square" lIns="43200" rIns="43200" tIns="64800" bIns="36000"/>
           <a:lstStyle/>
           <a:p>
             <a:pPr algn="ctr"/>
             <a:r>
-              <a:rPr sz="800" b="1" i="0">
+              <a:rPr sz="2800" b="1" i="0">
                 <a:solidFill>
                   <a:srgbClr val="1A7A8A"/>
                 </a:solidFill>
               </a:rPr>
-              <a:t>3.0%</a:t>
+              <a:t>R2=0.87</a:t>
             </a:r>
           </a:p>
           <a:p>
             <a:pPr algn="ctr">
               <a:spcBef>
-                <a:spcPts val="200"/>
+                <a:spcPts val="400"/>
               </a:spcBef>
             </a:pPr>
             <a:r>
-              <a:rPr sz="600" b="0" i="0">
+              <a:rPr sz="2400" b="0" i="0">
                 <a:solidFill>
                   <a:srgbClr val="222222"/>
                 </a:solidFill>
               </a:rPr>
-              <a:t>Avg annual
-price growth</a:t>
-            </a:r>
-          </a:p>
-        </p:txBody>
-      </p:sp>
-      <p:sp>
-        <p:nvSpPr>
-          <p:cNvPr id="51" name="Rounded Rectangle 50"/>
+              <a:t>Model
+accuracy</a:t>
+            </a:r>
+          </a:p>
+        </p:txBody>
+      </p:sp>
+      <p:sp>
+        <p:nvSpPr>
+          <p:cNvPr id="38" name="Rounded Rectangle 37"/>
           <p:cNvSpPr/>
           <p:nvPr/>
         </p:nvSpPr>
         <p:spPr>
           <a:xfrm>
-            <a:off x="7704000" y="9453974"/>
-            <a:ext cx="6984000" cy="244800"/>
+            <a:off x="7704000" y="7329971"/>
+            <a:ext cx="6984000" cy="468000"/>
           </a:xfrm>
           <a:prstGeom prst="roundRect">
             <a:avLst>
@@ -6112,12 +5133,12 @@
           </a:fontRef>
         </p:style>
         <p:txBody>
-          <a:bodyPr rtlCol="0" anchor="ctr" wrap="square" lIns="79200" rIns="43200" tIns="28800" bIns="28800"/>
+          <a:bodyPr rtlCol="0" anchor="ctr" wrap="square" lIns="79200" rIns="43200" tIns="43200" bIns="43200"/>
           <a:lstStyle/>
           <a:p>
             <a:pPr algn="l"/>
             <a:r>
-              <a:rPr sz="850" b="1" i="0">
+              <a:rPr sz="2600" b="1" i="0">
                 <a:solidFill>
                   <a:srgbClr val="FFFFFF"/>
                 </a:solidFill>
@@ -6129,14 +5150,14 @@
       </p:sp>
       <p:sp>
         <p:nvSpPr>
-          <p:cNvPr id="52" name="TextBox 51"/>
+          <p:cNvPr id="39" name="TextBox 38"/>
           <p:cNvSpPr txBox="1"/>
           <p:nvPr/>
         </p:nvSpPr>
         <p:spPr>
           <a:xfrm>
-            <a:off x="7704000" y="9770774"/>
-            <a:ext cx="6984000" cy="162000"/>
+            <a:off x="7704000" y="7887971"/>
+            <a:ext cx="6984000" cy="234000"/>
           </a:xfrm>
           <a:prstGeom prst="rect">
             <a:avLst/>
@@ -6150,7 +5171,7 @@
           <a:lstStyle/>
           <a:p>
             <a:r>
-              <a:rPr sz="750" b="1" i="0">
+              <a:rPr sz="2600" b="1" i="0">
                 <a:solidFill>
                   <a:srgbClr val="1A7A8A"/>
                 </a:solidFill>
@@ -6162,14 +5183,14 @@
       </p:sp>
       <p:sp>
         <p:nvSpPr>
-          <p:cNvPr id="53" name="TextBox 52"/>
+          <p:cNvPr id="40" name="TextBox 39"/>
           <p:cNvSpPr txBox="1"/>
           <p:nvPr/>
         </p:nvSpPr>
         <p:spPr>
           <a:xfrm>
-            <a:off x="7704000" y="9968774"/>
-            <a:ext cx="6984000" cy="936000"/>
+            <a:off x="7704000" y="8186770"/>
+            <a:ext cx="6984000" cy="1800000"/>
           </a:xfrm>
           <a:prstGeom prst="rect">
             <a:avLst/>
@@ -6184,11 +5205,11 @@
           <a:p>
             <a:pPr>
               <a:spcAft>
-                <a:spcPts val="200"/>
+                <a:spcPts val="300"/>
               </a:spcAft>
             </a:pPr>
             <a:r>
-              <a:rPr sz="650" b="1" i="0">
+              <a:rPr sz="2400" b="1" i="0">
                 <a:solidFill>
                   <a:srgbClr val="1A7A8A"/>
                 </a:solidFill>
@@ -6196,22 +5217,22 @@
               <a:t>◆  </a:t>
             </a:r>
             <a:r>
-              <a:rPr sz="650" b="0" i="0">
+              <a:rPr sz="2400" b="0" i="0">
                 <a:solidFill>
                   <a:srgbClr val="222222"/>
                 </a:solidFill>
               </a:rPr>
-              <a:t>Realistic wait-and-save behaviour: agents defer purchase during high interest-rate periods, mirroring the observed post-2022 slowdown</a:t>
+              <a:t>Agents defer purchase in high interest-rate periods</a:t>
             </a:r>
           </a:p>
           <a:p>
             <a:pPr>
               <a:spcAft>
-                <a:spcPts val="200"/>
+                <a:spcPts val="300"/>
               </a:spcAft>
             </a:pPr>
             <a:r>
-              <a:rPr sz="650" b="1" i="0">
+              <a:rPr sz="2400" b="1" i="0">
                 <a:solidFill>
                   <a:srgbClr val="1A7A8A"/>
                 </a:solidFill>
@@ -6219,22 +5240,22 @@
               <a:t>◆  </a:t>
             </a:r>
             <a:r>
-              <a:rPr sz="650" b="0" i="0">
+              <a:rPr sz="2400" b="0" i="0">
                 <a:solidFill>
                   <a:srgbClr val="222222"/>
                 </a:solidFill>
               </a:rPr>
-              <a:t>Life-event cascades: marriage and promotion trigger housing upgrades; job loss extends saving periods by a mean +1.8 years</a:t>
+              <a:t>Job loss extends saving periods by a mean of 1.8 years</a:t>
             </a:r>
           </a:p>
           <a:p>
             <a:pPr>
               <a:spcAft>
-                <a:spcPts val="200"/>
+                <a:spcPts val="300"/>
               </a:spcAft>
             </a:pPr>
             <a:r>
-              <a:rPr sz="650" b="1" i="0">
+              <a:rPr sz="2400" b="1" i="0">
                 <a:solidFill>
                   <a:srgbClr val="1A7A8A"/>
                 </a:solidFill>
@@ -6242,26 +5263,26 @@
               <a:t>◆  </a:t>
             </a:r>
             <a:r>
-              <a:rPr sz="650" b="0" i="0">
+              <a:rPr sz="2400" b="0" i="0">
                 <a:solidFill>
                   <a:srgbClr val="222222"/>
                 </a:solidFill>
               </a:rPr>
-              <a:t>London agents delay first purchase by 2–4 years vs Northern England equivalents on equivalent salaries</a:t>
-            </a:r>
-          </a:p>
-        </p:txBody>
-      </p:sp>
-      <p:sp>
-        <p:nvSpPr>
-          <p:cNvPr id="54" name="TextBox 53"/>
+              <a:t>London agents delay first purchase by 2 to 4 years vs Northern equivalents</a:t>
+            </a:r>
+          </a:p>
+        </p:txBody>
+      </p:sp>
+      <p:sp>
+        <p:nvSpPr>
+          <p:cNvPr id="41" name="TextBox 40"/>
           <p:cNvSpPr txBox="1"/>
           <p:nvPr/>
         </p:nvSpPr>
         <p:spPr>
           <a:xfrm>
-            <a:off x="7704000" y="10958774"/>
-            <a:ext cx="6984000" cy="162000"/>
+            <a:off x="7704000" y="10076771"/>
+            <a:ext cx="6984000" cy="234000"/>
           </a:xfrm>
           <a:prstGeom prst="rect">
             <a:avLst/>
@@ -6275,7 +5296,7 @@
           <a:lstStyle/>
           <a:p>
             <a:r>
-              <a:rPr sz="750" b="1" i="0">
+              <a:rPr sz="2600" b="1" i="0">
                 <a:solidFill>
                   <a:srgbClr val="1A7A8A"/>
                 </a:solidFill>
@@ -6287,14 +5308,14 @@
       </p:sp>
       <p:sp>
         <p:nvSpPr>
-          <p:cNvPr id="55" name="TextBox 54"/>
+          <p:cNvPr id="42" name="TextBox 41"/>
           <p:cNvSpPr txBox="1"/>
           <p:nvPr/>
         </p:nvSpPr>
         <p:spPr>
           <a:xfrm>
-            <a:off x="7704000" y="11156774"/>
-            <a:ext cx="6984000" cy="936000"/>
+            <a:off x="7704000" y="10375570"/>
+            <a:ext cx="6984000" cy="2160000"/>
           </a:xfrm>
           <a:prstGeom prst="rect">
             <a:avLst/>
@@ -6309,11 +5330,11 @@
           <a:p>
             <a:pPr>
               <a:spcAft>
-                <a:spcPts val="200"/>
+                <a:spcPts val="300"/>
               </a:spcAft>
             </a:pPr>
             <a:r>
-              <a:rPr sz="650" b="1" i="0">
+              <a:rPr sz="2400" b="1" i="0">
                 <a:solidFill>
                   <a:srgbClr val="1A7A8A"/>
                 </a:solidFill>
@@ -6321,22 +5342,22 @@
               <a:t>★  </a:t>
             </a:r>
             <a:r>
-              <a:rPr sz="650" b="0" i="0">
+              <a:rPr sz="2400" b="0" i="0">
                 <a:solidFill>
                   <a:srgbClr val="222222"/>
                 </a:solidFill>
               </a:rPr>
-              <a:t>Help-to-Buy: accelerates homeownership for households earning £25k–£45k</a:t>
+              <a:t>Help-to-Buy: 12% homeownership gain, 8% price rise in eligible bands</a:t>
             </a:r>
           </a:p>
           <a:p>
             <a:pPr>
               <a:spcAft>
-                <a:spcPts val="200"/>
+                <a:spcPts val="300"/>
               </a:spcAft>
             </a:pPr>
             <a:r>
-              <a:rPr sz="650" b="1" i="0">
+              <a:rPr sz="2400" b="1" i="0">
                 <a:solidFill>
                   <a:srgbClr val="1A7A8A"/>
                 </a:solidFill>
@@ -6344,22 +5365,22 @@
               <a:t>★  </a:t>
             </a:r>
             <a:r>
-              <a:rPr sz="650" b="0" i="0">
+              <a:rPr sz="2400" b="0" i="0">
                 <a:solidFill>
                   <a:srgbClr val="222222"/>
                 </a:solidFill>
               </a:rPr>
-              <a:t>+2% interest rate shock: reduces transaction volume; extends saving periods by ~1.8 years</a:t>
+              <a:t>2% rate shock: 23% fewer transactions, saving periods up 1.8 years</a:t>
             </a:r>
           </a:p>
           <a:p>
             <a:pPr>
               <a:spcAft>
-                <a:spcPts val="200"/>
+                <a:spcPts val="300"/>
               </a:spcAft>
             </a:pPr>
             <a:r>
-              <a:rPr sz="650" b="1" i="0">
+              <a:rPr sz="2400" b="1" i="0">
                 <a:solidFill>
                   <a:srgbClr val="1A7A8A"/>
                 </a:solidFill>
@@ -6367,22 +5388,22 @@
               <a:t>★  </a:t>
             </a:r>
             <a:r>
-              <a:rPr sz="650" b="0" i="0">
+              <a:rPr sz="2400" b="0" i="0">
                 <a:solidFill>
                   <a:srgbClr val="222222"/>
                 </a:solidFill>
               </a:rPr>
-              <a:t>Shared ownership: most effective for households earning £25k–£40k</a:t>
+              <a:t>Shared ownership: most effective for 25k to 40k household income</a:t>
             </a:r>
           </a:p>
           <a:p>
             <a:pPr>
               <a:spcAft>
-                <a:spcPts val="200"/>
+                <a:spcPts val="300"/>
               </a:spcAft>
             </a:pPr>
             <a:r>
-              <a:rPr sz="650" b="1" i="0">
+              <a:rPr sz="2400" b="1" i="0">
                 <a:solidFill>
                   <a:srgbClr val="1A7A8A"/>
                 </a:solidFill>
@@ -6390,26 +5411,26 @@
               <a:t>★  </a:t>
             </a:r>
             <a:r>
-              <a:rPr sz="650" b="0" i="0">
+              <a:rPr sz="2400" b="0" i="0">
                 <a:solidFill>
                   <a:srgbClr val="222222"/>
                 </a:solidFill>
               </a:rPr>
-              <a:t>Stamp duty exemption: accelerates first-time buyer market entry</a:t>
-            </a:r>
-          </a:p>
-        </p:txBody>
-      </p:sp>
-      <p:sp>
-        <p:nvSpPr>
-          <p:cNvPr id="56" name="Rounded Rectangle 55"/>
+              <a:t>Stamp duty relief: first-time buyers enter market 8 months sooner</a:t>
+            </a:r>
+          </a:p>
+        </p:txBody>
+      </p:sp>
+      <p:sp>
+        <p:nvSpPr>
+          <p:cNvPr id="43" name="Rounded Rectangle 42"/>
           <p:cNvSpPr/>
           <p:nvPr/>
         </p:nvSpPr>
         <p:spPr>
           <a:xfrm>
-            <a:off x="7704000" y="12218774"/>
-            <a:ext cx="6984000" cy="244800"/>
+            <a:off x="7704000" y="12697571"/>
+            <a:ext cx="6984000" cy="468000"/>
           </a:xfrm>
           <a:prstGeom prst="roundRect">
             <a:avLst>
@@ -6438,31 +5459,31 @@
           </a:fontRef>
         </p:style>
         <p:txBody>
-          <a:bodyPr rtlCol="0" anchor="ctr" wrap="square" lIns="79200" rIns="43200" tIns="28800" bIns="28800"/>
+          <a:bodyPr rtlCol="0" anchor="ctr" wrap="square" lIns="79200" rIns="43200" tIns="43200" bIns="43200"/>
           <a:lstStyle/>
           <a:p>
             <a:pPr algn="l"/>
             <a:r>
-              <a:rPr sz="850" b="1" i="0">
+              <a:rPr sz="2600" b="1" i="0">
                 <a:solidFill>
                   <a:srgbClr val="FFFFFF"/>
                 </a:solidFill>
               </a:rPr>
-              <a:t>CONCLUSIONS &amp; FUTURE WORK</a:t>
-            </a:r>
-          </a:p>
-        </p:txBody>
-      </p:sp>
-      <p:sp>
-        <p:nvSpPr>
-          <p:cNvPr id="57" name="TextBox 56"/>
+              <a:t>AGENT ARCHITECTURE</a:t>
+            </a:r>
+          </a:p>
+        </p:txBody>
+      </p:sp>
+      <p:sp>
+        <p:nvSpPr>
+          <p:cNvPr id="44" name="TextBox 43"/>
           <p:cNvSpPr txBox="1"/>
           <p:nvPr/>
         </p:nvSpPr>
         <p:spPr>
           <a:xfrm>
-            <a:off x="7704000" y="12535575"/>
-            <a:ext cx="6984000" cy="684000"/>
+            <a:off x="7704000" y="13255570"/>
+            <a:ext cx="6984000" cy="2160000"/>
           </a:xfrm>
           <a:prstGeom prst="rect">
             <a:avLst/>
@@ -6477,30 +5498,160 @@
           <a:p>
             <a:pPr>
               <a:spcAft>
-                <a:spcPts val="200"/>
+                <a:spcPts val="300"/>
               </a:spcAft>
             </a:pPr>
             <a:r>
-              <a:rPr sz="650" b="0" i="0">
+              <a:rPr sz="2400" b="1" i="0">
+                <a:solidFill>
+                  <a:srgbClr val="1A7A8A"/>
+                </a:solidFill>
+              </a:rPr>
+              <a:t>▸  </a:t>
+            </a:r>
+            <a:r>
+              <a:rPr sz="2400" b="0" i="0">
                 <a:solidFill>
                   <a:srgbClr val="222222"/>
                 </a:solidFill>
               </a:rPr>
-              <a:t>This research demonstrates that LLM-driven agent-based modelling can reproduce realistic UK housing affordability dynamics. The hybrid approach — combining AI contextual reasoning with rigorous financial algorithms — provides a powerful new framework for housing policy simulation, capturing individual-level decision patterns absent from traditional econometric models.</a:t>
-            </a:r>
-          </a:p>
-        </p:txBody>
-      </p:sp>
-      <p:sp>
-        <p:nvSpPr>
-          <p:cNvPr id="58" name="TextBox 57"/>
+              <a:t>PropertySearchTool: Land Registry fuzzy search by region, type and budget</a:t>
+            </a:r>
+          </a:p>
+          <a:p>
+            <a:pPr>
+              <a:spcAft>
+                <a:spcPts val="300"/>
+              </a:spcAft>
+            </a:pPr>
+            <a:r>
+              <a:rPr sz="2400" b="1" i="0">
+                <a:solidFill>
+                  <a:srgbClr val="1A7A8A"/>
+                </a:solidFill>
+              </a:rPr>
+              <a:t>▸  </a:t>
+            </a:r>
+            <a:r>
+              <a:rPr sz="2400" b="0" i="0">
+                <a:solidFill>
+                  <a:srgbClr val="222222"/>
+                </a:solidFill>
+              </a:rPr>
+              <a:t>MortgageCalcTool: LTV ratios, monthly payments and stress tests</a:t>
+            </a:r>
+          </a:p>
+          <a:p>
+            <a:pPr>
+              <a:spcAft>
+                <a:spcPts val="300"/>
+              </a:spcAft>
+            </a:pPr>
+            <a:r>
+              <a:rPr sz="2400" b="1" i="0">
+                <a:solidFill>
+                  <a:srgbClr val="1A7A8A"/>
+                </a:solidFill>
+              </a:rPr>
+              <a:t>▸  </a:t>
+            </a:r>
+            <a:r>
+              <a:rPr sz="2400" b="0" i="0">
+                <a:solidFill>
+                  <a:srgbClr val="222222"/>
+                </a:solidFill>
+              </a:rPr>
+              <a:t>AffordabilityTool: income percentile, deposit and price ratio</a:t>
+            </a:r>
+          </a:p>
+          <a:p>
+            <a:pPr>
+              <a:spcAft>
+                <a:spcPts val="300"/>
+              </a:spcAft>
+            </a:pPr>
+            <a:r>
+              <a:rPr sz="2400" b="1" i="0">
+                <a:solidFill>
+                  <a:srgbClr val="1A7A8A"/>
+                </a:solidFill>
+              </a:rPr>
+              <a:t>▸  </a:t>
+            </a:r>
+            <a:r>
+              <a:rPr sz="2400" b="0" i="0">
+                <a:solidFill>
+                  <a:srgbClr val="222222"/>
+                </a:solidFill>
+              </a:rPr>
+              <a:t>FinancialHealthTool: savings trajectory, debt and disposable income</a:t>
+            </a:r>
+          </a:p>
+        </p:txBody>
+      </p:sp>
+      <p:sp>
+        <p:nvSpPr>
+          <p:cNvPr id="45" name="Rounded Rectangle 44"/>
+          <p:cNvSpPr/>
+          <p:nvPr/>
+        </p:nvSpPr>
+        <p:spPr>
+          <a:xfrm>
+            <a:off x="7704000" y="15577571"/>
+            <a:ext cx="6984000" cy="468000"/>
+          </a:xfrm>
+          <a:prstGeom prst="roundRect">
+            <a:avLst>
+              <a:gd name="adj" fmla="val 30000"/>
+            </a:avLst>
+          </a:prstGeom>
+          <a:solidFill>
+            <a:srgbClr val="1A7A8A"/>
+          </a:solidFill>
+          <a:ln>
+            <a:noFill/>
+          </a:ln>
+        </p:spPr>
+        <p:style>
+          <a:lnRef idx="1">
+            <a:schemeClr val="accent1"/>
+          </a:lnRef>
+          <a:fillRef idx="3">
+            <a:schemeClr val="accent1"/>
+          </a:fillRef>
+          <a:effectRef idx="2">
+            <a:schemeClr val="accent1"/>
+          </a:effectRef>
+          <a:fontRef idx="minor">
+            <a:schemeClr val="lt1"/>
+          </a:fontRef>
+        </p:style>
+        <p:txBody>
+          <a:bodyPr rtlCol="0" anchor="ctr" wrap="square" lIns="79200" rIns="43200" tIns="43200" bIns="43200"/>
+          <a:lstStyle/>
+          <a:p>
+            <a:pPr algn="l"/>
+            <a:r>
+              <a:rPr sz="2600" b="1" i="0">
+                <a:solidFill>
+                  <a:srgbClr val="FFFFFF"/>
+                </a:solidFill>
+              </a:rPr>
+              <a:t>CONCLUSIONS AND FUTURE WORK</a:t>
+            </a:r>
+          </a:p>
+        </p:txBody>
+      </p:sp>
+      <p:sp>
+        <p:nvSpPr>
+          <p:cNvPr id="46" name="TextBox 45"/>
           <p:cNvSpPr txBox="1"/>
           <p:nvPr/>
         </p:nvSpPr>
         <p:spPr>
           <a:xfrm>
-            <a:off x="7704000" y="13273574"/>
-            <a:ext cx="6984000" cy="1007999"/>
+            <a:off x="7704000" y="16135570"/>
+            <a:ext cx="6984000" cy="1620000"/>
           </a:xfrm>
           <a:prstGeom prst="rect">
             <a:avLst/>
@@ -6515,116 +5666,195 @@
           <a:p>
             <a:pPr>
               <a:spcAft>
-                <a:spcPts val="200"/>
+                <a:spcPts val="300"/>
               </a:spcAft>
             </a:pPr>
             <a:r>
-              <a:rPr sz="650" b="1" i="0">
+              <a:rPr sz="2400" b="1" i="0">
                 <a:solidFill>
                   <a:srgbClr val="1A7A8A"/>
                 </a:solidFill>
               </a:rPr>
-              <a:t>→  </a:t>
-            </a:r>
-            <a:r>
-              <a:rPr sz="650" b="0" i="0">
+              <a:t>✓  </a:t>
+            </a:r>
+            <a:r>
+              <a:rPr sz="2400" b="0" i="0">
                 <a:solidFill>
                   <a:srgbClr val="222222"/>
                 </a:solidFill>
               </a:rPr>
-              <a:t>Add seller and lender agents for full market-side modelling</a:t>
+              <a:t>LLM-driven ABM reproduces realistic UK housing affordability dynamics</a:t>
             </a:r>
           </a:p>
           <a:p>
             <a:pPr>
               <a:spcAft>
-                <a:spcPts val="200"/>
+                <a:spcPts val="300"/>
               </a:spcAft>
             </a:pPr>
             <a:r>
-              <a:rPr sz="650" b="1" i="0">
+              <a:rPr sz="2400" b="1" i="0">
                 <a:solidFill>
                   <a:srgbClr val="1A7A8A"/>
                 </a:solidFill>
               </a:rPr>
-              <a:t>→  </a:t>
-            </a:r>
-            <a:r>
-              <a:rPr sz="650" b="0" i="0">
+              <a:t>✓  </a:t>
+            </a:r>
+            <a:r>
+              <a:rPr sz="2400" b="0" i="0">
                 <a:solidFill>
                   <a:srgbClr val="222222"/>
                 </a:solidFill>
               </a:rPr>
-              <a:t>Incorporate spatial neighbourhood &amp; commuter-belt effects</a:t>
+              <a:t>Hybrid AI and algorithm approach outperforms traditional econometric models</a:t>
             </a:r>
           </a:p>
           <a:p>
             <a:pPr>
               <a:spcAft>
-                <a:spcPts val="200"/>
+                <a:spcPts val="300"/>
               </a:spcAft>
             </a:pPr>
             <a:r>
-              <a:rPr sz="650" b="1" i="0">
+              <a:rPr sz="2400" b="1" i="0">
                 <a:solidFill>
                   <a:srgbClr val="1A7A8A"/>
                 </a:solidFill>
               </a:rPr>
-              <a:t>→  </a:t>
-            </a:r>
-            <a:r>
-              <a:rPr sz="650" b="0" i="0">
+              <a:t>✓  </a:t>
+            </a:r>
+            <a:r>
+              <a:rPr sz="2400" b="0" i="0">
                 <a:solidFill>
                   <a:srgbClr val="222222"/>
                 </a:solidFill>
               </a:rPr>
-              <a:t>Model new-build supply-side construction pipeline dynamics</a:t>
-            </a:r>
-          </a:p>
+              <a:t>Framework enables testing across multiple policy intervention scenarios</a:t>
+            </a:r>
+          </a:p>
+        </p:txBody>
+      </p:sp>
+      <p:sp>
+        <p:nvSpPr>
+          <p:cNvPr id="47" name="TextBox 46"/>
+          <p:cNvSpPr txBox="1"/>
+          <p:nvPr/>
+        </p:nvSpPr>
+        <p:spPr>
+          <a:xfrm>
+            <a:off x="7704000" y="17863570"/>
+            <a:ext cx="6984000" cy="234000"/>
+          </a:xfrm>
+          <a:prstGeom prst="rect">
+            <a:avLst/>
+          </a:prstGeom>
+          <a:noFill/>
+        </p:spPr>
+        <p:txBody>
+          <a:bodyPr wrap="none">
+            <a:spAutoFit/>
+          </a:bodyPr>
+          <a:lstStyle/>
+          <a:p>
+            <a:r>
+              <a:rPr sz="2600" b="1" i="0">
+                <a:solidFill>
+                  <a:srgbClr val="1A7A8A"/>
+                </a:solidFill>
+              </a:rPr>
+              <a:t>Future Work</a:t>
+            </a:r>
+          </a:p>
+        </p:txBody>
+      </p:sp>
+      <p:sp>
+        <p:nvSpPr>
+          <p:cNvPr id="48" name="TextBox 47"/>
+          <p:cNvSpPr txBox="1"/>
+          <p:nvPr/>
+        </p:nvSpPr>
+        <p:spPr>
+          <a:xfrm>
+            <a:off x="7704000" y="18162370"/>
+            <a:ext cx="6984000" cy="1620000"/>
+          </a:xfrm>
+          <a:prstGeom prst="rect">
+            <a:avLst/>
+          </a:prstGeom>
+          <a:noFill/>
+        </p:spPr>
+        <p:txBody>
+          <a:bodyPr wrap="square" lIns="0" rIns="0" tIns="0" bIns="0">
+            <a:spAutoFit/>
+          </a:bodyPr>
+          <a:lstStyle/>
           <a:p>
             <a:pPr>
               <a:spcAft>
-                <a:spcPts val="200"/>
+                <a:spcPts val="300"/>
               </a:spcAft>
             </a:pPr>
             <a:r>
-              <a:rPr sz="650" b="1" i="0">
+              <a:rPr sz="2400" b="1" i="0">
                 <a:solidFill>
                   <a:srgbClr val="1A7A8A"/>
                 </a:solidFill>
               </a:rPr>
-              <a:t>→  </a:t>
-            </a:r>
-            <a:r>
-              <a:rPr sz="650" b="0" i="0">
+              <a:t>▸  </a:t>
+            </a:r>
+            <a:r>
+              <a:rPr sz="2400" b="0" i="0">
                 <a:solidFill>
                   <a:srgbClr val="222222"/>
                 </a:solidFill>
               </a:rPr>
-              <a:t>Extend to Scottish, Welsh &amp; Northern Irish housing markets</a:t>
+              <a:t>Add seller and lender agents for full market-side modelling</a:t>
             </a:r>
           </a:p>
           <a:p>
             <a:pPr>
               <a:spcAft>
-                <a:spcPts val="200"/>
+                <a:spcPts val="300"/>
               </a:spcAft>
             </a:pPr>
             <a:r>
-              <a:rPr sz="650" b="1" i="0">
+              <a:rPr sz="2400" b="1" i="0">
                 <a:solidFill>
                   <a:srgbClr val="1A7A8A"/>
                 </a:solidFill>
               </a:rPr>
-              <a:t>→  </a:t>
-            </a:r>
-            <a:r>
-              <a:rPr sz="650" b="0" i="0">
+              <a:t>▸  </a:t>
+            </a:r>
+            <a:r>
+              <a:rPr sz="2400" b="0" i="0">
                 <a:solidFill>
                   <a:srgbClr val="222222"/>
                 </a:solidFill>
               </a:rPr>
-              <a:t>Real-time API integration with Rightmove / Zoopla live data</a:t>
+              <a:t>Incorporate spatial neighbourhood and commuter-belt effects</a:t>
+            </a:r>
+          </a:p>
+          <a:p>
+            <a:pPr>
+              <a:spcAft>
+                <a:spcPts val="300"/>
+              </a:spcAft>
+            </a:pPr>
+            <a:r>
+              <a:rPr sz="2400" b="1" i="0">
+                <a:solidFill>
+                  <a:srgbClr val="1A7A8A"/>
+                </a:solidFill>
+              </a:rPr>
+              <a:t>▸  </a:t>
+            </a:r>
+            <a:r>
+              <a:rPr sz="2400" b="0" i="0">
+                <a:solidFill>
+                  <a:srgbClr val="222222"/>
+                </a:solidFill>
+              </a:rPr>
+              <a:t>Extend to Scottish, Welsh and Northern Irish housing markets</a:t>
             </a:r>
           </a:p>
         </p:txBody>

</xml_diff>